<commit_message>
Extend deck with Tank-to-Wake framing (9 -> 11 slides)
Adds the Tank-to-Wake three-stage framework (pre-combustion,
combustion, post-combustion) and the compounding-losses argument
as the closing two slides, so the measured Section 01 data lands
inside the framework the company already uses. Each Section 01
slide is mapped to the stage it evidences.

Also reframes the MGO slide banner around ECA fuel switching, and
changes the separator-scope slide to hand off to the wider framework
rather than straight to Section 02.

Source for the new material: Wilhelmsen Ships Service articles on
holistic fuel management, pre-combustion treatment, and MGO
management in ECAs.

Co-Authored-By: Claude Opus 5 <noreply@anthropic.com>
Claude-Session: https://claude.ai/code/session_0181AXsH7YB1d1u5cHBfg2wM
</commit_message>
<xml_diff>
--- a/deck/fuel_section01.pptx
+++ b/deck/fuel_section01.pptx
@@ -14,9 +14,11 @@
     <p:sldId id="262" r:id="rId8"/>
     <p:sldId id="263" r:id="rId9"/>
     <p:sldId id="264" r:id="rId10"/>
+    <p:sldId id="265" r:id="rId11"/>
+    <p:sldId id="266" r:id="rId12"/>
   </p:sldIdLst>
   <p:notesMasterIdLst>
-    <p:notesMasterId r:id="rId11"/>
+    <p:notesMasterId r:id="rId13"/>
   </p:notesMasterIdLst>
   <p:sldSz cx="12192000" cy="6858000"/>
   <p:notesSz cx="6858000" cy="12192000"/>
@@ -1181,6 +1183,182 @@
             <a:fld id="{F7021451-1387-4CA6-816F-3879F97B5CBC}" type="slidenum">
               <a:rPr lang="en-US"/>
               <a:t>1</a:t>
+            </a:fld>
+            <a:endParaRPr lang="en-US"/>
+          </a:p>
+        </p:txBody>
+      </p:sp>
+    </p:spTree>
+    <p:extLst>
+      <p:ext uri="{BB962C8B-B14F-4D97-AF65-F5344CB8AC3E}">
+        <p14:creationId xmlns:p14="http://schemas.microsoft.com/office/powerpoint/2010/main" val="1024086991"/>
+      </p:ext>
+    </p:extLst>
+  </p:cSld>
+  <p:clrMapOvr>
+    <a:masterClrMapping/>
+  </p:clrMapOvr>
+</p:notes>
+</file>
+
+<file path=ppt/notesSlides/notesSlide10.xml><?xml version="1.0" encoding="utf-8"?>
+<p:notes xmlns:a="http://schemas.openxmlformats.org/drawingml/2006/main" xmlns:r="http://schemas.openxmlformats.org/officeDocument/2006/relationships" xmlns:p="http://schemas.openxmlformats.org/presentationml/2006/main">
+  <p:cSld>
+    <p:spTree>
+      <p:nvGrpSpPr>
+        <p:cNvPr id="1" name=""/>
+        <p:cNvGrpSpPr/>
+        <p:nvPr/>
+      </p:nvGrpSpPr>
+      <p:grpSpPr>
+        <a:xfrm>
+          <a:off x="0" y="0"/>
+          <a:ext cx="0" cy="0"/>
+          <a:chOff x="0" y="0"/>
+          <a:chExt cx="0" cy="0"/>
+        </a:xfrm>
+      </p:grpSpPr>
+      <p:sp>
+        <p:nvSpPr>
+          <p:cNvPr id="2" name="Slide Image Placeholder 1"/>
+          <p:cNvSpPr>
+            <a:spLocks noGrp="1" noRot="1" noChangeAspect="1"/>
+          </p:cNvSpPr>
+          <p:nvPr>
+            <p:ph type="sldImg"/>
+          </p:nvPr>
+        </p:nvSpPr>
+        <p:spPr/>
+      </p:sp>
+      <p:sp>
+        <p:nvSpPr>
+          <p:cNvPr id="3" name="Notes Placeholder 2"/>
+          <p:cNvSpPr>
+            <a:spLocks noGrp="1"/>
+          </p:cNvSpPr>
+          <p:nvPr>
+            <p:ph type="body" idx="1"/>
+          </p:nvPr>
+        </p:nvSpPr>
+        <p:spPr/>
+        <p:txBody>
+          <a:bodyPr/>
+          <a:lstStyle/>
+          <a:p>
+            <a:r>
+              <a:rPr lang="en-US" dirty="0"/>
+              <a:t>여기서 관점을 바꿉니다. 지금까지 본 문제들은 흩어진 개별 사건이 아니라 하나의 계통에서 일어나는 일입니다. Well-to-Wake는 추출·정제·수송까지 포함하는 규제 보고의 틀입니다. 반면 Tank-to-Wake는 연료가 우리 탱크에 들어온 순간부터 배기가 굴뚝을 빠져나갈 때까지 — 즉 본선이 실제로 손댈 수 있는 구간입니다. Section 01에서 본 데이터가 이 세 단계에 각각 어디에 해당하는지 카드 하단에 표시했습니다.</a:t>
+            </a:r>
+            <a:endParaRPr lang="en-US" dirty="0"/>
+          </a:p>
+        </p:txBody>
+      </p:sp>
+      <p:sp>
+        <p:nvSpPr>
+          <p:cNvPr id="4" name="Slide Number Placeholder 3"/>
+          <p:cNvSpPr>
+            <a:spLocks noGrp="1"/>
+          </p:cNvSpPr>
+          <p:nvPr>
+            <p:ph type="sldNum" sz="quarter" idx="10"/>
+          </p:nvPr>
+        </p:nvSpPr>
+        <p:spPr/>
+        <p:txBody>
+          <a:bodyPr/>
+          <a:lstStyle/>
+          <a:p>
+            <a:fld id="{F7021451-1387-4CA6-816F-3879F97B5CBC}" type="slidenum">
+              <a:rPr lang="en-US"/>
+              <a:t>10</a:t>
+            </a:fld>
+            <a:endParaRPr lang="en-US"/>
+          </a:p>
+        </p:txBody>
+      </p:sp>
+    </p:spTree>
+    <p:extLst>
+      <p:ext uri="{BB962C8B-B14F-4D97-AF65-F5344CB8AC3E}">
+        <p14:creationId xmlns:p14="http://schemas.microsoft.com/office/powerpoint/2010/main" val="1024086991"/>
+      </p:ext>
+    </p:extLst>
+  </p:cSld>
+  <p:clrMapOvr>
+    <a:masterClrMapping/>
+  </p:clrMapOvr>
+</p:notes>
+</file>
+
+<file path=ppt/notesSlides/notesSlide11.xml><?xml version="1.0" encoding="utf-8"?>
+<p:notes xmlns:a="http://schemas.openxmlformats.org/drawingml/2006/main" xmlns:r="http://schemas.openxmlformats.org/officeDocument/2006/relationships" xmlns:p="http://schemas.openxmlformats.org/presentationml/2006/main">
+  <p:cSld>
+    <p:spTree>
+      <p:nvGrpSpPr>
+        <p:cNvPr id="1" name=""/>
+        <p:cNvGrpSpPr/>
+        <p:nvPr/>
+      </p:nvGrpSpPr>
+      <p:grpSpPr>
+        <a:xfrm>
+          <a:off x="0" y="0"/>
+          <a:ext cx="0" cy="0"/>
+          <a:chOff x="0" y="0"/>
+          <a:chExt cx="0" cy="0"/>
+        </a:xfrm>
+      </p:grpSpPr>
+      <p:sp>
+        <p:nvSpPr>
+          <p:cNvPr id="2" name="Slide Image Placeholder 1"/>
+          <p:cNvSpPr>
+            <a:spLocks noGrp="1" noRot="1" noChangeAspect="1"/>
+          </p:cNvSpPr>
+          <p:nvPr>
+            <p:ph type="sldImg"/>
+          </p:nvPr>
+        </p:nvSpPr>
+        <p:spPr/>
+      </p:sp>
+      <p:sp>
+        <p:nvSpPr>
+          <p:cNvPr id="3" name="Notes Placeholder 2"/>
+          <p:cNvSpPr>
+            <a:spLocks noGrp="1"/>
+          </p:cNvSpPr>
+          <p:nvPr>
+            <p:ph type="body" idx="1"/>
+          </p:nvPr>
+        </p:nvSpPr>
+        <p:spPr/>
+        <p:txBody>
+          <a:bodyPr/>
+          <a:lstStyle/>
+          <a:p>
+            <a:r>
+              <a:rPr lang="en-US" dirty="0"/>
+              <a:t>Section 01의 마지막 장입니다. 핵심은 손실이 단계마다 누적된다는 점입니다. 저장 중 열화로 슬러지가 되면 그 연료는 엔진에 도달조차 못 합니다. 연소가 나쁘면 매연이 열회수면에 쌓여 이후 모든 사이클의 효율을 떨어뜨립니다. 그래서 한 지점만 개선하는 것으로는 부족하고, Tank-to-Wake 전체를 하나로 관리해야 합니다. Section 02부터 각 단계를 순서대로 다룹니다.</a:t>
+            </a:r>
+            <a:endParaRPr lang="en-US" dirty="0"/>
+          </a:p>
+        </p:txBody>
+      </p:sp>
+      <p:sp>
+        <p:nvSpPr>
+          <p:cNvPr id="4" name="Slide Number Placeholder 3"/>
+          <p:cNvSpPr>
+            <a:spLocks noGrp="1"/>
+          </p:cNvSpPr>
+          <p:nvPr>
+            <p:ph type="sldNum" sz="quarter" idx="10"/>
+          </p:nvPr>
+        </p:nvSpPr>
+        <p:spPr/>
+        <p:txBody>
+          <a:bodyPr/>
+          <a:lstStyle/>
+          <a:p>
+            <a:fld id="{F7021451-1387-4CA6-816F-3879F97B5CBC}" type="slidenum">
+              <a:rPr lang="en-US"/>
+              <a:t>11</a:t>
             </a:fld>
             <a:endParaRPr lang="en-US"/>
           </a:p>
@@ -2857,6 +3035,3517 @@
               <a:t>01</a:t>
             </a:r>
             <a:endParaRPr lang="en-US" sz="950" dirty="0"/>
+          </a:p>
+        </p:txBody>
+      </p:sp>
+    </p:spTree>
+  </p:cSld>
+  <p:clrMapOvr>
+    <a:masterClrMapping/>
+  </p:clrMapOvr>
+</p:sld>
+</file>
+
+<file path=ppt/slides/slide10.xml><?xml version="1.0" encoding="utf-8"?>
+<p:sld xmlns:a="http://schemas.openxmlformats.org/drawingml/2006/main" xmlns:r="http://schemas.openxmlformats.org/officeDocument/2006/relationships" xmlns:p="http://schemas.openxmlformats.org/presentationml/2006/main">
+  <p:cSld name="Slide 10">
+    <p:bg>
+      <p:bgPr>
+        <a:solidFill>
+          <a:srgbClr val="F4F6FB"/>
+        </a:solidFill>
+      </p:bgPr>
+    </p:bg>
+    <p:spTree>
+      <p:nvGrpSpPr>
+        <p:cNvPr id="1" name=""/>
+        <p:cNvGrpSpPr/>
+        <p:nvPr/>
+      </p:nvGrpSpPr>
+      <p:grpSpPr>
+        <a:xfrm>
+          <a:off x="0" y="0"/>
+          <a:ext cx="0" cy="0"/>
+          <a:chOff x="0" y="0"/>
+          <a:chExt cx="0" cy="0"/>
+        </a:xfrm>
+      </p:grpSpPr>
+      <p:sp>
+        <p:nvSpPr>
+          <p:cNvPr id="2" name="Text 0"/>
+          <p:cNvSpPr/>
+          <p:nvPr/>
+        </p:nvSpPr>
+        <p:spPr>
+          <a:xfrm>
+            <a:off x="566928" y="402336"/>
+            <a:ext cx="7315200" cy="256032"/>
+          </a:xfrm>
+          <a:prstGeom prst="rect">
+            <a:avLst/>
+          </a:prstGeom>
+          <a:noFill/>
+          <a:ln/>
+        </p:spPr>
+        <p:txBody>
+          <a:bodyPr wrap="square" lIns="0" tIns="0" rIns="0" bIns="0" rtlCol="0" anchor="ctr"/>
+          <a:lstStyle/>
+          <a:p>
+            <a:pPr algn="l" indent="0" marL="0">
+              <a:buNone/>
+            </a:pPr>
+            <a:r>
+              <a:rPr lang="en-US" sz="1150" b="1" spc="240" kern="0" dirty="0">
+                <a:solidFill>
+                  <a:srgbClr val="E17B34"/>
+                </a:solidFill>
+                <a:latin typeface="맑은 고딕" pitchFamily="34" charset="0"/>
+                <a:ea typeface="맑은 고딕" pitchFamily="34" charset="-122"/>
+                <a:cs typeface="맑은 고딕" pitchFamily="34" charset="-120"/>
+              </a:rPr>
+              <a:t>09   프레임</a:t>
+            </a:r>
+            <a:endParaRPr lang="en-US" sz="1150" dirty="0"/>
+          </a:p>
+        </p:txBody>
+      </p:sp>
+      <p:sp>
+        <p:nvSpPr>
+          <p:cNvPr id="3" name="Text 1"/>
+          <p:cNvSpPr/>
+          <p:nvPr/>
+        </p:nvSpPr>
+        <p:spPr>
+          <a:xfrm>
+            <a:off x="566928" y="694944"/>
+            <a:ext cx="11057839" cy="713232"/>
+          </a:xfrm>
+          <a:prstGeom prst="rect">
+            <a:avLst/>
+          </a:prstGeom>
+          <a:noFill/>
+          <a:ln/>
+        </p:spPr>
+        <p:txBody>
+          <a:bodyPr wrap="square" lIns="0" tIns="0" rIns="0" bIns="0" rtlCol="0" anchor="ctr"/>
+          <a:lstStyle/>
+          <a:p>
+            <a:pPr algn="l" indent="0" marL="0">
+              <a:buNone/>
+            </a:pPr>
+            <a:r>
+              <a:rPr lang="en-US" sz="3600" dirty="0">
+                <a:solidFill>
+                  <a:srgbClr val="1B3A5C"/>
+                </a:solidFill>
+                <a:latin typeface="바탕" pitchFamily="34" charset="0"/>
+                <a:ea typeface="바탕" pitchFamily="34" charset="-122"/>
+                <a:cs typeface="바탕" pitchFamily="34" charset="-120"/>
+              </a:rPr>
+              <a:t>Tank to Wake — 탱크에서 배기까지</a:t>
+            </a:r>
+            <a:endParaRPr lang="en-US" sz="3600" dirty="0"/>
+          </a:p>
+        </p:txBody>
+      </p:sp>
+      <p:sp>
+        <p:nvSpPr>
+          <p:cNvPr id="4" name="Text 2"/>
+          <p:cNvSpPr/>
+          <p:nvPr/>
+        </p:nvSpPr>
+        <p:spPr>
+          <a:xfrm>
+            <a:off x="566928" y="6419088"/>
+            <a:ext cx="8778240" cy="274320"/>
+          </a:xfrm>
+          <a:prstGeom prst="rect">
+            <a:avLst/>
+          </a:prstGeom>
+          <a:noFill/>
+          <a:ln/>
+        </p:spPr>
+        <p:txBody>
+          <a:bodyPr wrap="square" lIns="0" tIns="0" rIns="0" bIns="0" rtlCol="0" anchor="ctr"/>
+          <a:lstStyle/>
+          <a:p>
+            <a:pPr indent="0" marL="0">
+              <a:buNone/>
+            </a:pPr>
+            <a:r>
+              <a:rPr lang="en-US" sz="850" dirty="0">
+                <a:solidFill>
+                  <a:srgbClr val="8A94A6"/>
+                </a:solidFill>
+                <a:latin typeface="맑은 고딕" pitchFamily="34" charset="0"/>
+                <a:ea typeface="맑은 고딕" pitchFamily="34" charset="-122"/>
+                <a:cs typeface="맑은 고딕" pitchFamily="34" charset="-120"/>
+              </a:rPr>
+              <a:t>Classified as Internal - This content is proprietary information intended for employees and partners only.</a:t>
+            </a:r>
+            <a:endParaRPr lang="en-US" sz="850" dirty="0"/>
+          </a:p>
+        </p:txBody>
+      </p:sp>
+      <p:sp>
+        <p:nvSpPr>
+          <p:cNvPr id="5" name="Text 3"/>
+          <p:cNvSpPr/>
+          <p:nvPr/>
+        </p:nvSpPr>
+        <p:spPr>
+          <a:xfrm>
+            <a:off x="11155680" y="6419088"/>
+            <a:ext cx="502920" cy="274320"/>
+          </a:xfrm>
+          <a:prstGeom prst="rect">
+            <a:avLst/>
+          </a:prstGeom>
+          <a:noFill/>
+          <a:ln/>
+        </p:spPr>
+        <p:txBody>
+          <a:bodyPr wrap="square" lIns="0" tIns="0" rIns="0" bIns="0" rtlCol="0" anchor="ctr"/>
+          <a:lstStyle/>
+          <a:p>
+            <a:pPr algn="r" indent="0" marL="0">
+              <a:buNone/>
+            </a:pPr>
+            <a:r>
+              <a:rPr lang="en-US" sz="950" dirty="0">
+                <a:solidFill>
+                  <a:srgbClr val="8A94A6"/>
+                </a:solidFill>
+                <a:latin typeface="맑은 고딕" pitchFamily="34" charset="0"/>
+                <a:ea typeface="맑은 고딕" pitchFamily="34" charset="-122"/>
+                <a:cs typeface="맑은 고딕" pitchFamily="34" charset="-120"/>
+              </a:rPr>
+              <a:t>10</a:t>
+            </a:r>
+            <a:endParaRPr lang="en-US" sz="950" dirty="0"/>
+          </a:p>
+        </p:txBody>
+      </p:sp>
+      <p:sp>
+        <p:nvSpPr>
+          <p:cNvPr id="6" name="Shape 4"/>
+          <p:cNvSpPr/>
+          <p:nvPr/>
+        </p:nvSpPr>
+        <p:spPr>
+          <a:xfrm>
+            <a:off x="566928" y="1591056"/>
+            <a:ext cx="3429914" cy="3017520"/>
+          </a:xfrm>
+          <a:prstGeom prst="roundRect">
+            <a:avLst>
+              <a:gd name="adj" fmla="val 4242"/>
+            </a:avLst>
+          </a:prstGeom>
+          <a:solidFill>
+            <a:srgbClr val="FFFFFF"/>
+          </a:solidFill>
+          <a:ln w="9525">
+            <a:solidFill>
+              <a:srgbClr val="EDF1F8"/>
+            </a:solidFill>
+            <a:prstDash val="solid"/>
+          </a:ln>
+          <a:effectLst>
+            <a:outerShdw sx="100000" sy="100000" kx="0" ky="0" algn="bl" rotWithShape="0" blurRad="127000" dist="25400" dir="5400000">
+              <a:srgbClr val="9BAAC4">
+                <a:alpha val="22000"/>
+              </a:srgbClr>
+            </a:outerShdw>
+          </a:effectLst>
+        </p:spPr>
+      </p:sp>
+      <p:sp>
+        <p:nvSpPr>
+          <p:cNvPr id="7" name="Text 5"/>
+          <p:cNvSpPr/>
+          <p:nvPr/>
+        </p:nvSpPr>
+        <p:spPr>
+          <a:xfrm>
+            <a:off x="804672" y="1792224"/>
+            <a:ext cx="2954426" cy="219456"/>
+          </a:xfrm>
+          <a:prstGeom prst="rect">
+            <a:avLst/>
+          </a:prstGeom>
+          <a:noFill/>
+          <a:ln/>
+        </p:spPr>
+        <p:txBody>
+          <a:bodyPr wrap="square" lIns="0" tIns="0" rIns="0" bIns="0" rtlCol="0" anchor="ctr"/>
+          <a:lstStyle/>
+          <a:p>
+            <a:pPr indent="0" marL="0">
+              <a:buNone/>
+            </a:pPr>
+            <a:r>
+              <a:rPr lang="en-US" sz="950" b="1" spc="180" kern="0" dirty="0">
+                <a:solidFill>
+                  <a:srgbClr val="2E5C8A"/>
+                </a:solidFill>
+                <a:latin typeface="맑은 고딕" pitchFamily="34" charset="0"/>
+                <a:ea typeface="맑은 고딕" pitchFamily="34" charset="-122"/>
+                <a:cs typeface="맑은 고딕" pitchFamily="34" charset="-120"/>
+              </a:rPr>
+              <a:t>PRE-COMBUSTION</a:t>
+            </a:r>
+            <a:endParaRPr lang="en-US" sz="950" dirty="0"/>
+          </a:p>
+        </p:txBody>
+      </p:sp>
+      <p:sp>
+        <p:nvSpPr>
+          <p:cNvPr id="8" name="Text 6"/>
+          <p:cNvSpPr/>
+          <p:nvPr/>
+        </p:nvSpPr>
+        <p:spPr>
+          <a:xfrm>
+            <a:off x="804672" y="2011680"/>
+            <a:ext cx="2954426" cy="384048"/>
+          </a:xfrm>
+          <a:prstGeom prst="rect">
+            <a:avLst/>
+          </a:prstGeom>
+          <a:noFill/>
+          <a:ln/>
+        </p:spPr>
+        <p:txBody>
+          <a:bodyPr wrap="square" lIns="0" tIns="0" rIns="0" bIns="0" rtlCol="0" anchor="ctr"/>
+          <a:lstStyle/>
+          <a:p>
+            <a:pPr indent="0" marL="0">
+              <a:buNone/>
+            </a:pPr>
+            <a:r>
+              <a:rPr lang="en-US" sz="2200" dirty="0">
+                <a:solidFill>
+                  <a:srgbClr val="1B3A5C"/>
+                </a:solidFill>
+                <a:latin typeface="바탕" pitchFamily="34" charset="0"/>
+                <a:ea typeface="바탕" pitchFamily="34" charset="-122"/>
+                <a:cs typeface="바탕" pitchFamily="34" charset="-120"/>
+              </a:rPr>
+              <a:t>연소 전</a:t>
+            </a:r>
+            <a:endParaRPr lang="en-US" sz="2200" dirty="0"/>
+          </a:p>
+        </p:txBody>
+      </p:sp>
+      <p:sp>
+        <p:nvSpPr>
+          <p:cNvPr id="9" name="Text 7"/>
+          <p:cNvSpPr/>
+          <p:nvPr/>
+        </p:nvSpPr>
+        <p:spPr>
+          <a:xfrm>
+            <a:off x="804672" y="2414016"/>
+            <a:ext cx="2954426" cy="256032"/>
+          </a:xfrm>
+          <a:prstGeom prst="rect">
+            <a:avLst/>
+          </a:prstGeom>
+          <a:noFill/>
+          <a:ln/>
+        </p:spPr>
+        <p:txBody>
+          <a:bodyPr wrap="square" lIns="0" tIns="0" rIns="0" bIns="0" rtlCol="0" anchor="ctr"/>
+          <a:lstStyle/>
+          <a:p>
+            <a:pPr indent="0" marL="0">
+              <a:buNone/>
+            </a:pPr>
+            <a:r>
+              <a:rPr lang="en-US" sz="1100" b="1" dirty="0">
+                <a:solidFill>
+                  <a:srgbClr val="2E5C8A"/>
+                </a:solidFill>
+                <a:latin typeface="맑은 고딕" pitchFamily="34" charset="0"/>
+                <a:ea typeface="맑은 고딕" pitchFamily="34" charset="-122"/>
+                <a:cs typeface="맑은 고딕" pitchFamily="34" charset="-120"/>
+              </a:rPr>
+              <a:t>저장 · 안정성 · 호환성</a:t>
+            </a:r>
+            <a:endParaRPr lang="en-US" sz="1100" dirty="0"/>
+          </a:p>
+        </p:txBody>
+      </p:sp>
+      <p:sp>
+        <p:nvSpPr>
+          <p:cNvPr id="10" name="Shape 8"/>
+          <p:cNvSpPr/>
+          <p:nvPr/>
+        </p:nvSpPr>
+        <p:spPr>
+          <a:xfrm>
+            <a:off x="822960" y="2852928"/>
+            <a:ext cx="109728" cy="109728"/>
+          </a:xfrm>
+          <a:prstGeom prst="roundRect">
+            <a:avLst>
+              <a:gd name="adj" fmla="val 50000"/>
+            </a:avLst>
+          </a:prstGeom>
+          <a:solidFill>
+            <a:srgbClr val="2E5C8A"/>
+          </a:solidFill>
+          <a:ln w="12700">
+            <a:solidFill>
+              <a:srgbClr val="333333"/>
+            </a:solidFill>
+            <a:prstDash val="solid"/>
+          </a:ln>
+        </p:spPr>
+      </p:sp>
+      <p:sp>
+        <p:nvSpPr>
+          <p:cNvPr id="11" name="Text 9"/>
+          <p:cNvSpPr/>
+          <p:nvPr/>
+        </p:nvSpPr>
+        <p:spPr>
+          <a:xfrm>
+            <a:off x="1042416" y="2761488"/>
+            <a:ext cx="2716682" cy="310896"/>
+          </a:xfrm>
+          <a:prstGeom prst="rect">
+            <a:avLst/>
+          </a:prstGeom>
+          <a:noFill/>
+          <a:ln/>
+        </p:spPr>
+        <p:txBody>
+          <a:bodyPr wrap="square" lIns="0" tIns="0" rIns="0" bIns="0" rtlCol="0" anchor="ctr"/>
+          <a:lstStyle/>
+          <a:p>
+            <a:pPr indent="0" marL="0">
+              <a:buNone/>
+            </a:pPr>
+            <a:r>
+              <a:rPr lang="en-US" sz="1050" dirty="0">
+                <a:solidFill>
+                  <a:srgbClr val="3D4A5C"/>
+                </a:solidFill>
+                <a:latin typeface="맑은 고딕" pitchFamily="34" charset="0"/>
+                <a:ea typeface="맑은 고딕" pitchFamily="34" charset="-122"/>
+                <a:cs typeface="맑은 고딕" pitchFamily="34" charset="-120"/>
+              </a:rPr>
+              <a:t>연료가 엔진에 도달하기 전 단계</a:t>
+            </a:r>
+            <a:endParaRPr lang="en-US" sz="1050" dirty="0"/>
+          </a:p>
+        </p:txBody>
+      </p:sp>
+      <p:sp>
+        <p:nvSpPr>
+          <p:cNvPr id="12" name="Shape 10"/>
+          <p:cNvSpPr/>
+          <p:nvPr/>
+        </p:nvSpPr>
+        <p:spPr>
+          <a:xfrm>
+            <a:off x="822960" y="3218688"/>
+            <a:ext cx="109728" cy="109728"/>
+          </a:xfrm>
+          <a:prstGeom prst="roundRect">
+            <a:avLst>
+              <a:gd name="adj" fmla="val 50000"/>
+            </a:avLst>
+          </a:prstGeom>
+          <a:solidFill>
+            <a:srgbClr val="2E5C8A"/>
+          </a:solidFill>
+          <a:ln w="12700">
+            <a:solidFill>
+              <a:srgbClr val="333333"/>
+            </a:solidFill>
+            <a:prstDash val="solid"/>
+          </a:ln>
+        </p:spPr>
+      </p:sp>
+      <p:sp>
+        <p:nvSpPr>
+          <p:cNvPr id="13" name="Text 11"/>
+          <p:cNvSpPr/>
+          <p:nvPr/>
+        </p:nvSpPr>
+        <p:spPr>
+          <a:xfrm>
+            <a:off x="1042416" y="3127248"/>
+            <a:ext cx="2716682" cy="310896"/>
+          </a:xfrm>
+          <a:prstGeom prst="rect">
+            <a:avLst/>
+          </a:prstGeom>
+          <a:noFill/>
+          <a:ln/>
+        </p:spPr>
+        <p:txBody>
+          <a:bodyPr wrap="square" lIns="0" tIns="0" rIns="0" bIns="0" rtlCol="0" anchor="ctr"/>
+          <a:lstStyle/>
+          <a:p>
+            <a:pPr indent="0" marL="0">
+              <a:buNone/>
+            </a:pPr>
+            <a:r>
+              <a:rPr lang="en-US" sz="1050" dirty="0">
+                <a:solidFill>
+                  <a:srgbClr val="3D4A5C"/>
+                </a:solidFill>
+                <a:latin typeface="맑은 고딕" pitchFamily="34" charset="0"/>
+                <a:ea typeface="맑은 고딕" pitchFamily="34" charset="-122"/>
+                <a:cs typeface="맑은 고딕" pitchFamily="34" charset="-120"/>
+              </a:rPr>
+              <a:t>슬러지로 빠져나가는 손실</a:t>
+            </a:r>
+            <a:endParaRPr lang="en-US" sz="1050" dirty="0"/>
+          </a:p>
+        </p:txBody>
+      </p:sp>
+      <p:sp>
+        <p:nvSpPr>
+          <p:cNvPr id="14" name="Shape 12"/>
+          <p:cNvSpPr/>
+          <p:nvPr/>
+        </p:nvSpPr>
+        <p:spPr>
+          <a:xfrm>
+            <a:off x="822960" y="3584448"/>
+            <a:ext cx="109728" cy="109728"/>
+          </a:xfrm>
+          <a:prstGeom prst="roundRect">
+            <a:avLst>
+              <a:gd name="adj" fmla="val 50000"/>
+            </a:avLst>
+          </a:prstGeom>
+          <a:solidFill>
+            <a:srgbClr val="2E5C8A"/>
+          </a:solidFill>
+          <a:ln w="12700">
+            <a:solidFill>
+              <a:srgbClr val="333333"/>
+            </a:solidFill>
+            <a:prstDash val="solid"/>
+          </a:ln>
+        </p:spPr>
+      </p:sp>
+      <p:sp>
+        <p:nvSpPr>
+          <p:cNvPr id="15" name="Text 13"/>
+          <p:cNvSpPr/>
+          <p:nvPr/>
+        </p:nvSpPr>
+        <p:spPr>
+          <a:xfrm>
+            <a:off x="1042416" y="3493008"/>
+            <a:ext cx="2716682" cy="310896"/>
+          </a:xfrm>
+          <a:prstGeom prst="rect">
+            <a:avLst/>
+          </a:prstGeom>
+          <a:noFill/>
+          <a:ln/>
+        </p:spPr>
+        <p:txBody>
+          <a:bodyPr wrap="square" lIns="0" tIns="0" rIns="0" bIns="0" rtlCol="0" anchor="ctr"/>
+          <a:lstStyle/>
+          <a:p>
+            <a:pPr indent="0" marL="0">
+              <a:buNone/>
+            </a:pPr>
+            <a:r>
+              <a:rPr lang="en-US" sz="1050" dirty="0">
+                <a:solidFill>
+                  <a:srgbClr val="3D4A5C"/>
+                </a:solidFill>
+                <a:latin typeface="맑은 고딕" pitchFamily="34" charset="0"/>
+                <a:ea typeface="맑은 고딕" pitchFamily="34" charset="-122"/>
+                <a:cs typeface="맑은 고딕" pitchFamily="34" charset="-120"/>
+              </a:rPr>
+              <a:t>정유기 · 필터 부하</a:t>
+            </a:r>
+            <a:endParaRPr lang="en-US" sz="1050" dirty="0"/>
+          </a:p>
+        </p:txBody>
+      </p:sp>
+      <p:sp>
+        <p:nvSpPr>
+          <p:cNvPr id="16" name="Shape 14"/>
+          <p:cNvSpPr/>
+          <p:nvPr/>
+        </p:nvSpPr>
+        <p:spPr>
+          <a:xfrm>
+            <a:off x="804672" y="3986784"/>
+            <a:ext cx="2954426" cy="402336"/>
+          </a:xfrm>
+          <a:prstGeom prst="roundRect">
+            <a:avLst>
+              <a:gd name="adj" fmla="val 15909"/>
+            </a:avLst>
+          </a:prstGeom>
+          <a:solidFill>
+            <a:srgbClr val="EEF2F9"/>
+          </a:solidFill>
+          <a:ln w="12700">
+            <a:solidFill>
+              <a:srgbClr val="333333"/>
+            </a:solidFill>
+            <a:prstDash val="solid"/>
+          </a:ln>
+        </p:spPr>
+      </p:sp>
+      <p:sp>
+        <p:nvSpPr>
+          <p:cNvPr id="17" name="Text 15"/>
+          <p:cNvSpPr/>
+          <p:nvPr/>
+        </p:nvSpPr>
+        <p:spPr>
+          <a:xfrm>
+            <a:off x="804672" y="3986784"/>
+            <a:ext cx="2954426" cy="402336"/>
+          </a:xfrm>
+          <a:prstGeom prst="rect">
+            <a:avLst/>
+          </a:prstGeom>
+          <a:noFill/>
+          <a:ln/>
+        </p:spPr>
+        <p:txBody>
+          <a:bodyPr wrap="square" lIns="0" tIns="0" rIns="0" bIns="0" rtlCol="0" anchor="ctr"/>
+          <a:lstStyle/>
+          <a:p>
+            <a:pPr algn="ctr" indent="0" marL="0">
+              <a:buNone/>
+            </a:pPr>
+            <a:r>
+              <a:rPr lang="en-US" sz="950" b="1" spc="60" kern="0" dirty="0">
+                <a:solidFill>
+                  <a:srgbClr val="2E5C8A"/>
+                </a:solidFill>
+                <a:latin typeface="맑은 고딕" pitchFamily="34" charset="0"/>
+                <a:ea typeface="맑은 고딕" pitchFamily="34" charset="-122"/>
+                <a:cs typeface="맑은 고딕" pitchFamily="34" charset="-120"/>
+              </a:rPr>
+              <a:t>Section 01 근거  05 · 06 · 07</a:t>
+            </a:r>
+            <a:endParaRPr lang="en-US" sz="950" dirty="0"/>
+          </a:p>
+        </p:txBody>
+      </p:sp>
+      <p:sp>
+        <p:nvSpPr>
+          <p:cNvPr id="18" name="Text 16"/>
+          <p:cNvSpPr/>
+          <p:nvPr/>
+        </p:nvSpPr>
+        <p:spPr>
+          <a:xfrm>
+            <a:off x="4024274" y="2926080"/>
+            <a:ext cx="329184" cy="365760"/>
+          </a:xfrm>
+          <a:prstGeom prst="rect">
+            <a:avLst/>
+          </a:prstGeom>
+          <a:noFill/>
+          <a:ln/>
+        </p:spPr>
+        <p:txBody>
+          <a:bodyPr wrap="square" lIns="0" tIns="0" rIns="0" bIns="0" rtlCol="0" anchor="ctr"/>
+          <a:lstStyle/>
+          <a:p>
+            <a:pPr algn="ctr" indent="0" marL="0">
+              <a:buNone/>
+            </a:pPr>
+            <a:r>
+              <a:rPr lang="en-US" sz="1400" dirty="0">
+                <a:solidFill>
+                  <a:srgbClr val="B9C4D6"/>
+                </a:solidFill>
+                <a:latin typeface="맑은 고딕" pitchFamily="34" charset="0"/>
+                <a:ea typeface="맑은 고딕" pitchFamily="34" charset="-122"/>
+                <a:cs typeface="맑은 고딕" pitchFamily="34" charset="-120"/>
+              </a:rPr>
+              <a:t>▶</a:t>
+            </a:r>
+            <a:endParaRPr lang="en-US" sz="1400" dirty="0"/>
+          </a:p>
+        </p:txBody>
+      </p:sp>
+      <p:sp>
+        <p:nvSpPr>
+          <p:cNvPr id="19" name="Shape 17"/>
+          <p:cNvSpPr/>
+          <p:nvPr/>
+        </p:nvSpPr>
+        <p:spPr>
+          <a:xfrm>
+            <a:off x="4380890" y="1591056"/>
+            <a:ext cx="3429914" cy="3017520"/>
+          </a:xfrm>
+          <a:prstGeom prst="roundRect">
+            <a:avLst>
+              <a:gd name="adj" fmla="val 4242"/>
+            </a:avLst>
+          </a:prstGeom>
+          <a:solidFill>
+            <a:srgbClr val="FFFFFF"/>
+          </a:solidFill>
+          <a:ln w="9525">
+            <a:solidFill>
+              <a:srgbClr val="EDF1F8"/>
+            </a:solidFill>
+            <a:prstDash val="solid"/>
+          </a:ln>
+          <a:effectLst>
+            <a:outerShdw sx="100000" sy="100000" kx="0" ky="0" algn="bl" rotWithShape="0" blurRad="127000" dist="25400" dir="5400000">
+              <a:srgbClr val="9BAAC4">
+                <a:alpha val="22000"/>
+              </a:srgbClr>
+            </a:outerShdw>
+          </a:effectLst>
+        </p:spPr>
+      </p:sp>
+      <p:sp>
+        <p:nvSpPr>
+          <p:cNvPr id="20" name="Text 18"/>
+          <p:cNvSpPr/>
+          <p:nvPr/>
+        </p:nvSpPr>
+        <p:spPr>
+          <a:xfrm>
+            <a:off x="4618634" y="1792224"/>
+            <a:ext cx="2954426" cy="219456"/>
+          </a:xfrm>
+          <a:prstGeom prst="rect">
+            <a:avLst/>
+          </a:prstGeom>
+          <a:noFill/>
+          <a:ln/>
+        </p:spPr>
+        <p:txBody>
+          <a:bodyPr wrap="square" lIns="0" tIns="0" rIns="0" bIns="0" rtlCol="0" anchor="ctr"/>
+          <a:lstStyle/>
+          <a:p>
+            <a:pPr indent="0" marL="0">
+              <a:buNone/>
+            </a:pPr>
+            <a:r>
+              <a:rPr lang="en-US" sz="950" b="1" spc="180" kern="0" dirty="0">
+                <a:solidFill>
+                  <a:srgbClr val="E17B34"/>
+                </a:solidFill>
+                <a:latin typeface="맑은 고딕" pitchFamily="34" charset="0"/>
+                <a:ea typeface="맑은 고딕" pitchFamily="34" charset="-122"/>
+                <a:cs typeface="맑은 고딕" pitchFamily="34" charset="-120"/>
+              </a:rPr>
+              <a:t>COMBUSTION</a:t>
+            </a:r>
+            <a:endParaRPr lang="en-US" sz="950" dirty="0"/>
+          </a:p>
+        </p:txBody>
+      </p:sp>
+      <p:sp>
+        <p:nvSpPr>
+          <p:cNvPr id="21" name="Text 19"/>
+          <p:cNvSpPr/>
+          <p:nvPr/>
+        </p:nvSpPr>
+        <p:spPr>
+          <a:xfrm>
+            <a:off x="4618634" y="2011680"/>
+            <a:ext cx="2954426" cy="384048"/>
+          </a:xfrm>
+          <a:prstGeom prst="rect">
+            <a:avLst/>
+          </a:prstGeom>
+          <a:noFill/>
+          <a:ln/>
+        </p:spPr>
+        <p:txBody>
+          <a:bodyPr wrap="square" lIns="0" tIns="0" rIns="0" bIns="0" rtlCol="0" anchor="ctr"/>
+          <a:lstStyle/>
+          <a:p>
+            <a:pPr indent="0" marL="0">
+              <a:buNone/>
+            </a:pPr>
+            <a:r>
+              <a:rPr lang="en-US" sz="2200" dirty="0">
+                <a:solidFill>
+                  <a:srgbClr val="1B3A5C"/>
+                </a:solidFill>
+                <a:latin typeface="바탕" pitchFamily="34" charset="0"/>
+                <a:ea typeface="바탕" pitchFamily="34" charset="-122"/>
+                <a:cs typeface="바탕" pitchFamily="34" charset="-120"/>
+              </a:rPr>
+              <a:t>연소</a:t>
+            </a:r>
+            <a:endParaRPr lang="en-US" sz="2200" dirty="0"/>
+          </a:p>
+        </p:txBody>
+      </p:sp>
+      <p:sp>
+        <p:nvSpPr>
+          <p:cNvPr id="22" name="Text 20"/>
+          <p:cNvSpPr/>
+          <p:nvPr/>
+        </p:nvSpPr>
+        <p:spPr>
+          <a:xfrm>
+            <a:off x="4618634" y="2414016"/>
+            <a:ext cx="2954426" cy="256032"/>
+          </a:xfrm>
+          <a:prstGeom prst="rect">
+            <a:avLst/>
+          </a:prstGeom>
+          <a:noFill/>
+          <a:ln/>
+        </p:spPr>
+        <p:txBody>
+          <a:bodyPr wrap="square" lIns="0" tIns="0" rIns="0" bIns="0" rtlCol="0" anchor="ctr"/>
+          <a:lstStyle/>
+          <a:p>
+            <a:pPr indent="0" marL="0">
+              <a:buNone/>
+            </a:pPr>
+            <a:r>
+              <a:rPr lang="en-US" sz="1100" b="1" dirty="0">
+                <a:solidFill>
+                  <a:srgbClr val="E17B34"/>
+                </a:solidFill>
+                <a:latin typeface="맑은 고딕" pitchFamily="34" charset="0"/>
+                <a:ea typeface="맑은 고딕" pitchFamily="34" charset="-122"/>
+                <a:cs typeface="맑은 고딕" pitchFamily="34" charset="-120"/>
+              </a:rPr>
+              <a:t>연소 효율 · 무화 · 에너지 변환</a:t>
+            </a:r>
+            <a:endParaRPr lang="en-US" sz="1100" dirty="0"/>
+          </a:p>
+        </p:txBody>
+      </p:sp>
+      <p:sp>
+        <p:nvSpPr>
+          <p:cNvPr id="23" name="Shape 21"/>
+          <p:cNvSpPr/>
+          <p:nvPr/>
+        </p:nvSpPr>
+        <p:spPr>
+          <a:xfrm>
+            <a:off x="4636922" y="2852928"/>
+            <a:ext cx="109728" cy="109728"/>
+          </a:xfrm>
+          <a:prstGeom prst="roundRect">
+            <a:avLst>
+              <a:gd name="adj" fmla="val 50000"/>
+            </a:avLst>
+          </a:prstGeom>
+          <a:solidFill>
+            <a:srgbClr val="E17B34"/>
+          </a:solidFill>
+          <a:ln w="12700">
+            <a:solidFill>
+              <a:srgbClr val="333333"/>
+            </a:solidFill>
+            <a:prstDash val="solid"/>
+          </a:ln>
+        </p:spPr>
+      </p:sp>
+      <p:sp>
+        <p:nvSpPr>
+          <p:cNvPr id="24" name="Text 22"/>
+          <p:cNvSpPr/>
+          <p:nvPr/>
+        </p:nvSpPr>
+        <p:spPr>
+          <a:xfrm>
+            <a:off x="4856378" y="2761488"/>
+            <a:ext cx="2716682" cy="310896"/>
+          </a:xfrm>
+          <a:prstGeom prst="rect">
+            <a:avLst/>
+          </a:prstGeom>
+          <a:noFill/>
+          <a:ln/>
+        </p:spPr>
+        <p:txBody>
+          <a:bodyPr wrap="square" lIns="0" tIns="0" rIns="0" bIns="0" rtlCol="0" anchor="ctr"/>
+          <a:lstStyle/>
+          <a:p>
+            <a:pPr indent="0" marL="0">
+              <a:buNone/>
+            </a:pPr>
+            <a:r>
+              <a:rPr lang="en-US" sz="1050" dirty="0">
+                <a:solidFill>
+                  <a:srgbClr val="3D4A5C"/>
+                </a:solidFill>
+                <a:latin typeface="맑은 고딕" pitchFamily="34" charset="0"/>
+                <a:ea typeface="맑은 고딕" pitchFamily="34" charset="-122"/>
+                <a:cs typeface="맑은 고딕" pitchFamily="34" charset="-120"/>
+              </a:rPr>
+              <a:t>연료가 실제로 일로 바뀌는 단계</a:t>
+            </a:r>
+            <a:endParaRPr lang="en-US" sz="1050" dirty="0"/>
+          </a:p>
+        </p:txBody>
+      </p:sp>
+      <p:sp>
+        <p:nvSpPr>
+          <p:cNvPr id="25" name="Shape 23"/>
+          <p:cNvSpPr/>
+          <p:nvPr/>
+        </p:nvSpPr>
+        <p:spPr>
+          <a:xfrm>
+            <a:off x="4636922" y="3218688"/>
+            <a:ext cx="109728" cy="109728"/>
+          </a:xfrm>
+          <a:prstGeom prst="roundRect">
+            <a:avLst>
+              <a:gd name="adj" fmla="val 50000"/>
+            </a:avLst>
+          </a:prstGeom>
+          <a:solidFill>
+            <a:srgbClr val="E17B34"/>
+          </a:solidFill>
+          <a:ln w="12700">
+            <a:solidFill>
+              <a:srgbClr val="333333"/>
+            </a:solidFill>
+            <a:prstDash val="solid"/>
+          </a:ln>
+        </p:spPr>
+      </p:sp>
+      <p:sp>
+        <p:nvSpPr>
+          <p:cNvPr id="26" name="Text 24"/>
+          <p:cNvSpPr/>
+          <p:nvPr/>
+        </p:nvSpPr>
+        <p:spPr>
+          <a:xfrm>
+            <a:off x="4856378" y="3127248"/>
+            <a:ext cx="2716682" cy="310896"/>
+          </a:xfrm>
+          <a:prstGeom prst="rect">
+            <a:avLst/>
+          </a:prstGeom>
+          <a:noFill/>
+          <a:ln/>
+        </p:spPr>
+        <p:txBody>
+          <a:bodyPr wrap="square" lIns="0" tIns="0" rIns="0" bIns="0" rtlCol="0" anchor="ctr"/>
+          <a:lstStyle/>
+          <a:p>
+            <a:pPr indent="0" marL="0">
+              <a:buNone/>
+            </a:pPr>
+            <a:r>
+              <a:rPr lang="en-US" sz="1050" dirty="0">
+                <a:solidFill>
+                  <a:srgbClr val="3D4A5C"/>
+                </a:solidFill>
+                <a:latin typeface="맑은 고딕" pitchFamily="34" charset="0"/>
+                <a:ea typeface="맑은 고딕" pitchFamily="34" charset="-122"/>
+                <a:cs typeface="맑은 고딕" pitchFamily="34" charset="-120"/>
+              </a:rPr>
+              <a:t>점도 · 잔류탄소분의 영향</a:t>
+            </a:r>
+            <a:endParaRPr lang="en-US" sz="1050" dirty="0"/>
+          </a:p>
+        </p:txBody>
+      </p:sp>
+      <p:sp>
+        <p:nvSpPr>
+          <p:cNvPr id="27" name="Shape 25"/>
+          <p:cNvSpPr/>
+          <p:nvPr/>
+        </p:nvSpPr>
+        <p:spPr>
+          <a:xfrm>
+            <a:off x="4636922" y="3584448"/>
+            <a:ext cx="109728" cy="109728"/>
+          </a:xfrm>
+          <a:prstGeom prst="roundRect">
+            <a:avLst>
+              <a:gd name="adj" fmla="val 50000"/>
+            </a:avLst>
+          </a:prstGeom>
+          <a:solidFill>
+            <a:srgbClr val="E17B34"/>
+          </a:solidFill>
+          <a:ln w="12700">
+            <a:solidFill>
+              <a:srgbClr val="333333"/>
+            </a:solidFill>
+            <a:prstDash val="solid"/>
+          </a:ln>
+        </p:spPr>
+      </p:sp>
+      <p:sp>
+        <p:nvSpPr>
+          <p:cNvPr id="28" name="Text 26"/>
+          <p:cNvSpPr/>
+          <p:nvPr/>
+        </p:nvSpPr>
+        <p:spPr>
+          <a:xfrm>
+            <a:off x="4856378" y="3493008"/>
+            <a:ext cx="2716682" cy="310896"/>
+          </a:xfrm>
+          <a:prstGeom prst="rect">
+            <a:avLst/>
+          </a:prstGeom>
+          <a:noFill/>
+          <a:ln/>
+        </p:spPr>
+        <p:txBody>
+          <a:bodyPr wrap="square" lIns="0" tIns="0" rIns="0" bIns="0" rtlCol="0" anchor="ctr"/>
+          <a:lstStyle/>
+          <a:p>
+            <a:pPr indent="0" marL="0">
+              <a:buNone/>
+            </a:pPr>
+            <a:r>
+              <a:rPr lang="en-US" sz="1050" dirty="0">
+                <a:solidFill>
+                  <a:srgbClr val="3D4A5C"/>
+                </a:solidFill>
+                <a:latin typeface="맑은 고딕" pitchFamily="34" charset="0"/>
+                <a:ea typeface="맑은 고딕" pitchFamily="34" charset="-122"/>
+                <a:cs typeface="맑은 고딕" pitchFamily="34" charset="-120"/>
+              </a:rPr>
+              <a:t>분사 상태와 착화 품질</a:t>
+            </a:r>
+            <a:endParaRPr lang="en-US" sz="1050" dirty="0"/>
+          </a:p>
+        </p:txBody>
+      </p:sp>
+      <p:sp>
+        <p:nvSpPr>
+          <p:cNvPr id="29" name="Shape 27"/>
+          <p:cNvSpPr/>
+          <p:nvPr/>
+        </p:nvSpPr>
+        <p:spPr>
+          <a:xfrm>
+            <a:off x="4618634" y="3986784"/>
+            <a:ext cx="2954426" cy="402336"/>
+          </a:xfrm>
+          <a:prstGeom prst="roundRect">
+            <a:avLst>
+              <a:gd name="adj" fmla="val 15909"/>
+            </a:avLst>
+          </a:prstGeom>
+          <a:solidFill>
+            <a:srgbClr val="FDF2E9"/>
+          </a:solidFill>
+          <a:ln w="12700">
+            <a:solidFill>
+              <a:srgbClr val="333333"/>
+            </a:solidFill>
+            <a:prstDash val="solid"/>
+          </a:ln>
+        </p:spPr>
+      </p:sp>
+      <p:sp>
+        <p:nvSpPr>
+          <p:cNvPr id="30" name="Text 28"/>
+          <p:cNvSpPr/>
+          <p:nvPr/>
+        </p:nvSpPr>
+        <p:spPr>
+          <a:xfrm>
+            <a:off x="4618634" y="3986784"/>
+            <a:ext cx="2954426" cy="402336"/>
+          </a:xfrm>
+          <a:prstGeom prst="rect">
+            <a:avLst/>
+          </a:prstGeom>
+          <a:noFill/>
+          <a:ln/>
+        </p:spPr>
+        <p:txBody>
+          <a:bodyPr wrap="square" lIns="0" tIns="0" rIns="0" bIns="0" rtlCol="0" anchor="ctr"/>
+          <a:lstStyle/>
+          <a:p>
+            <a:pPr algn="ctr" indent="0" marL="0">
+              <a:buNone/>
+            </a:pPr>
+            <a:r>
+              <a:rPr lang="en-US" sz="950" b="1" spc="60" kern="0" dirty="0">
+                <a:solidFill>
+                  <a:srgbClr val="E17B34"/>
+                </a:solidFill>
+                <a:latin typeface="맑은 고딕" pitchFamily="34" charset="0"/>
+                <a:ea typeface="맑은 고딕" pitchFamily="34" charset="-122"/>
+                <a:cs typeface="맑은 고딕" pitchFamily="34" charset="-120"/>
+              </a:rPr>
+              <a:t>Section 01 근거  04</a:t>
+            </a:r>
+            <a:endParaRPr lang="en-US" sz="950" dirty="0"/>
+          </a:p>
+        </p:txBody>
+      </p:sp>
+      <p:sp>
+        <p:nvSpPr>
+          <p:cNvPr id="31" name="Text 29"/>
+          <p:cNvSpPr/>
+          <p:nvPr/>
+        </p:nvSpPr>
+        <p:spPr>
+          <a:xfrm>
+            <a:off x="7838237" y="2926080"/>
+            <a:ext cx="329184" cy="365760"/>
+          </a:xfrm>
+          <a:prstGeom prst="rect">
+            <a:avLst/>
+          </a:prstGeom>
+          <a:noFill/>
+          <a:ln/>
+        </p:spPr>
+        <p:txBody>
+          <a:bodyPr wrap="square" lIns="0" tIns="0" rIns="0" bIns="0" rtlCol="0" anchor="ctr"/>
+          <a:lstStyle/>
+          <a:p>
+            <a:pPr algn="ctr" indent="0" marL="0">
+              <a:buNone/>
+            </a:pPr>
+            <a:r>
+              <a:rPr lang="en-US" sz="1400" dirty="0">
+                <a:solidFill>
+                  <a:srgbClr val="B9C4D6"/>
+                </a:solidFill>
+                <a:latin typeface="맑은 고딕" pitchFamily="34" charset="0"/>
+                <a:ea typeface="맑은 고딕" pitchFamily="34" charset="-122"/>
+                <a:cs typeface="맑은 고딕" pitchFamily="34" charset="-120"/>
+              </a:rPr>
+              <a:t>▶</a:t>
+            </a:r>
+            <a:endParaRPr lang="en-US" sz="1400" dirty="0"/>
+          </a:p>
+        </p:txBody>
+      </p:sp>
+      <p:sp>
+        <p:nvSpPr>
+          <p:cNvPr id="32" name="Shape 30"/>
+          <p:cNvSpPr/>
+          <p:nvPr/>
+        </p:nvSpPr>
+        <p:spPr>
+          <a:xfrm>
+            <a:off x="8194853" y="1591056"/>
+            <a:ext cx="3429914" cy="3017520"/>
+          </a:xfrm>
+          <a:prstGeom prst="roundRect">
+            <a:avLst>
+              <a:gd name="adj" fmla="val 4242"/>
+            </a:avLst>
+          </a:prstGeom>
+          <a:solidFill>
+            <a:srgbClr val="FFFFFF"/>
+          </a:solidFill>
+          <a:ln w="9525">
+            <a:solidFill>
+              <a:srgbClr val="EDF1F8"/>
+            </a:solidFill>
+            <a:prstDash val="solid"/>
+          </a:ln>
+          <a:effectLst>
+            <a:outerShdw sx="100000" sy="100000" kx="0" ky="0" algn="bl" rotWithShape="0" blurRad="127000" dist="25400" dir="5400000">
+              <a:srgbClr val="9BAAC4">
+                <a:alpha val="22000"/>
+              </a:srgbClr>
+            </a:outerShdw>
+          </a:effectLst>
+        </p:spPr>
+      </p:sp>
+      <p:sp>
+        <p:nvSpPr>
+          <p:cNvPr id="33" name="Text 31"/>
+          <p:cNvSpPr/>
+          <p:nvPr/>
+        </p:nvSpPr>
+        <p:spPr>
+          <a:xfrm>
+            <a:off x="8432597" y="1792224"/>
+            <a:ext cx="2954426" cy="219456"/>
+          </a:xfrm>
+          <a:prstGeom prst="rect">
+            <a:avLst/>
+          </a:prstGeom>
+          <a:noFill/>
+          <a:ln/>
+        </p:spPr>
+        <p:txBody>
+          <a:bodyPr wrap="square" lIns="0" tIns="0" rIns="0" bIns="0" rtlCol="0" anchor="ctr"/>
+          <a:lstStyle/>
+          <a:p>
+            <a:pPr indent="0" marL="0">
+              <a:buNone/>
+            </a:pPr>
+            <a:r>
+              <a:rPr lang="en-US" sz="950" b="1" spc="180" kern="0" dirty="0">
+                <a:solidFill>
+                  <a:srgbClr val="2E7D5B"/>
+                </a:solidFill>
+                <a:latin typeface="맑은 고딕" pitchFamily="34" charset="0"/>
+                <a:ea typeface="맑은 고딕" pitchFamily="34" charset="-122"/>
+                <a:cs typeface="맑은 고딕" pitchFamily="34" charset="-120"/>
+              </a:rPr>
+              <a:t>POST-COMBUSTION</a:t>
+            </a:r>
+            <a:endParaRPr lang="en-US" sz="950" dirty="0"/>
+          </a:p>
+        </p:txBody>
+      </p:sp>
+      <p:sp>
+        <p:nvSpPr>
+          <p:cNvPr id="34" name="Text 32"/>
+          <p:cNvSpPr/>
+          <p:nvPr/>
+        </p:nvSpPr>
+        <p:spPr>
+          <a:xfrm>
+            <a:off x="8432597" y="2011680"/>
+            <a:ext cx="2954426" cy="384048"/>
+          </a:xfrm>
+          <a:prstGeom prst="rect">
+            <a:avLst/>
+          </a:prstGeom>
+          <a:noFill/>
+          <a:ln/>
+        </p:spPr>
+        <p:txBody>
+          <a:bodyPr wrap="square" lIns="0" tIns="0" rIns="0" bIns="0" rtlCol="0" anchor="ctr"/>
+          <a:lstStyle/>
+          <a:p>
+            <a:pPr indent="0" marL="0">
+              <a:buNone/>
+            </a:pPr>
+            <a:r>
+              <a:rPr lang="en-US" sz="2200" dirty="0">
+                <a:solidFill>
+                  <a:srgbClr val="1B3A5C"/>
+                </a:solidFill>
+                <a:latin typeface="바탕" pitchFamily="34" charset="0"/>
+                <a:ea typeface="바탕" pitchFamily="34" charset="-122"/>
+                <a:cs typeface="바탕" pitchFamily="34" charset="-120"/>
+              </a:rPr>
+              <a:t>연소 후</a:t>
+            </a:r>
+            <a:endParaRPr lang="en-US" sz="2200" dirty="0"/>
+          </a:p>
+        </p:txBody>
+      </p:sp>
+      <p:sp>
+        <p:nvSpPr>
+          <p:cNvPr id="35" name="Text 33"/>
+          <p:cNvSpPr/>
+          <p:nvPr/>
+        </p:nvSpPr>
+        <p:spPr>
+          <a:xfrm>
+            <a:off x="8432597" y="2414016"/>
+            <a:ext cx="2954426" cy="256032"/>
+          </a:xfrm>
+          <a:prstGeom prst="rect">
+            <a:avLst/>
+          </a:prstGeom>
+          <a:noFill/>
+          <a:ln/>
+        </p:spPr>
+        <p:txBody>
+          <a:bodyPr wrap="square" lIns="0" tIns="0" rIns="0" bIns="0" rtlCol="0" anchor="ctr"/>
+          <a:lstStyle/>
+          <a:p>
+            <a:pPr indent="0" marL="0">
+              <a:buNone/>
+            </a:pPr>
+            <a:r>
+              <a:rPr lang="en-US" sz="1100" b="1" dirty="0">
+                <a:solidFill>
+                  <a:srgbClr val="2E7D5B"/>
+                </a:solidFill>
+                <a:latin typeface="맑은 고딕" pitchFamily="34" charset="0"/>
+                <a:ea typeface="맑은 고딕" pitchFamily="34" charset="-122"/>
+                <a:cs typeface="맑은 고딕" pitchFamily="34" charset="-120"/>
+              </a:rPr>
+              <a:t>매연 제어 · 열회수 · 계통 청결</a:t>
+            </a:r>
+            <a:endParaRPr lang="en-US" sz="1100" dirty="0"/>
+          </a:p>
+        </p:txBody>
+      </p:sp>
+      <p:sp>
+        <p:nvSpPr>
+          <p:cNvPr id="36" name="Shape 34"/>
+          <p:cNvSpPr/>
+          <p:nvPr/>
+        </p:nvSpPr>
+        <p:spPr>
+          <a:xfrm>
+            <a:off x="8450885" y="2852928"/>
+            <a:ext cx="109728" cy="109728"/>
+          </a:xfrm>
+          <a:prstGeom prst="roundRect">
+            <a:avLst>
+              <a:gd name="adj" fmla="val 50000"/>
+            </a:avLst>
+          </a:prstGeom>
+          <a:solidFill>
+            <a:srgbClr val="2E7D5B"/>
+          </a:solidFill>
+          <a:ln w="12700">
+            <a:solidFill>
+              <a:srgbClr val="333333"/>
+            </a:solidFill>
+            <a:prstDash val="solid"/>
+          </a:ln>
+        </p:spPr>
+      </p:sp>
+      <p:sp>
+        <p:nvSpPr>
+          <p:cNvPr id="37" name="Text 35"/>
+          <p:cNvSpPr/>
+          <p:nvPr/>
+        </p:nvSpPr>
+        <p:spPr>
+          <a:xfrm>
+            <a:off x="8670341" y="2761488"/>
+            <a:ext cx="2716682" cy="310896"/>
+          </a:xfrm>
+          <a:prstGeom prst="rect">
+            <a:avLst/>
+          </a:prstGeom>
+          <a:noFill/>
+          <a:ln/>
+        </p:spPr>
+        <p:txBody>
+          <a:bodyPr wrap="square" lIns="0" tIns="0" rIns="0" bIns="0" rtlCol="0" anchor="ctr"/>
+          <a:lstStyle/>
+          <a:p>
+            <a:pPr indent="0" marL="0">
+              <a:buNone/>
+            </a:pPr>
+            <a:r>
+              <a:rPr lang="en-US" sz="1050" dirty="0">
+                <a:solidFill>
+                  <a:srgbClr val="3D4A5C"/>
+                </a:solidFill>
+                <a:latin typeface="맑은 고딕" pitchFamily="34" charset="0"/>
+                <a:ea typeface="맑은 고딕" pitchFamily="34" charset="-122"/>
+                <a:cs typeface="맑은 고딕" pitchFamily="34" charset="-120"/>
+              </a:rPr>
+              <a:t>배기가 계통을 빠져나가는 단계</a:t>
+            </a:r>
+            <a:endParaRPr lang="en-US" sz="1050" dirty="0"/>
+          </a:p>
+        </p:txBody>
+      </p:sp>
+      <p:sp>
+        <p:nvSpPr>
+          <p:cNvPr id="38" name="Shape 36"/>
+          <p:cNvSpPr/>
+          <p:nvPr/>
+        </p:nvSpPr>
+        <p:spPr>
+          <a:xfrm>
+            <a:off x="8450885" y="3218688"/>
+            <a:ext cx="109728" cy="109728"/>
+          </a:xfrm>
+          <a:prstGeom prst="roundRect">
+            <a:avLst>
+              <a:gd name="adj" fmla="val 50000"/>
+            </a:avLst>
+          </a:prstGeom>
+          <a:solidFill>
+            <a:srgbClr val="2E7D5B"/>
+          </a:solidFill>
+          <a:ln w="12700">
+            <a:solidFill>
+              <a:srgbClr val="333333"/>
+            </a:solidFill>
+            <a:prstDash val="solid"/>
+          </a:ln>
+        </p:spPr>
+      </p:sp>
+      <p:sp>
+        <p:nvSpPr>
+          <p:cNvPr id="39" name="Text 37"/>
+          <p:cNvSpPr/>
+          <p:nvPr/>
+        </p:nvSpPr>
+        <p:spPr>
+          <a:xfrm>
+            <a:off x="8670341" y="3127248"/>
+            <a:ext cx="2716682" cy="310896"/>
+          </a:xfrm>
+          <a:prstGeom prst="rect">
+            <a:avLst/>
+          </a:prstGeom>
+          <a:noFill/>
+          <a:ln/>
+        </p:spPr>
+        <p:txBody>
+          <a:bodyPr wrap="square" lIns="0" tIns="0" rIns="0" bIns="0" rtlCol="0" anchor="ctr"/>
+          <a:lstStyle/>
+          <a:p>
+            <a:pPr indent="0" marL="0">
+              <a:buNone/>
+            </a:pPr>
+            <a:r>
+              <a:rPr lang="en-US" sz="1050" dirty="0">
+                <a:solidFill>
+                  <a:srgbClr val="3D4A5C"/>
+                </a:solidFill>
+                <a:latin typeface="맑은 고딕" pitchFamily="34" charset="0"/>
+                <a:ea typeface="맑은 고딕" pitchFamily="34" charset="-122"/>
+                <a:cs typeface="맑은 고딕" pitchFamily="34" charset="-120"/>
+              </a:rPr>
+              <a:t>터보차저 · 열회수면 퇴적</a:t>
+            </a:r>
+            <a:endParaRPr lang="en-US" sz="1050" dirty="0"/>
+          </a:p>
+        </p:txBody>
+      </p:sp>
+      <p:sp>
+        <p:nvSpPr>
+          <p:cNvPr id="40" name="Shape 38"/>
+          <p:cNvSpPr/>
+          <p:nvPr/>
+        </p:nvSpPr>
+        <p:spPr>
+          <a:xfrm>
+            <a:off x="8450885" y="3584448"/>
+            <a:ext cx="109728" cy="109728"/>
+          </a:xfrm>
+          <a:prstGeom prst="roundRect">
+            <a:avLst>
+              <a:gd name="adj" fmla="val 50000"/>
+            </a:avLst>
+          </a:prstGeom>
+          <a:solidFill>
+            <a:srgbClr val="2E7D5B"/>
+          </a:solidFill>
+          <a:ln w="12700">
+            <a:solidFill>
+              <a:srgbClr val="333333"/>
+            </a:solidFill>
+            <a:prstDash val="solid"/>
+          </a:ln>
+        </p:spPr>
+      </p:sp>
+      <p:sp>
+        <p:nvSpPr>
+          <p:cNvPr id="41" name="Text 39"/>
+          <p:cNvSpPr/>
+          <p:nvPr/>
+        </p:nvSpPr>
+        <p:spPr>
+          <a:xfrm>
+            <a:off x="8670341" y="3493008"/>
+            <a:ext cx="2716682" cy="310896"/>
+          </a:xfrm>
+          <a:prstGeom prst="rect">
+            <a:avLst/>
+          </a:prstGeom>
+          <a:noFill/>
+          <a:ln/>
+        </p:spPr>
+        <p:txBody>
+          <a:bodyPr wrap="square" lIns="0" tIns="0" rIns="0" bIns="0" rtlCol="0" anchor="ctr"/>
+          <a:lstStyle/>
+          <a:p>
+            <a:pPr indent="0" marL="0">
+              <a:buNone/>
+            </a:pPr>
+            <a:r>
+              <a:rPr lang="en-US" sz="1050" dirty="0">
+                <a:solidFill>
+                  <a:srgbClr val="3D4A5C"/>
+                </a:solidFill>
+                <a:latin typeface="맑은 고딕" pitchFamily="34" charset="0"/>
+                <a:ea typeface="맑은 고딕" pitchFamily="34" charset="-122"/>
+                <a:cs typeface="맑은 고딕" pitchFamily="34" charset="-120"/>
+              </a:rPr>
+              <a:t>청소 주기와 배압</a:t>
+            </a:r>
+            <a:endParaRPr lang="en-US" sz="1050" dirty="0"/>
+          </a:p>
+        </p:txBody>
+      </p:sp>
+      <p:sp>
+        <p:nvSpPr>
+          <p:cNvPr id="42" name="Shape 40"/>
+          <p:cNvSpPr/>
+          <p:nvPr/>
+        </p:nvSpPr>
+        <p:spPr>
+          <a:xfrm>
+            <a:off x="8432597" y="3986784"/>
+            <a:ext cx="2954426" cy="402336"/>
+          </a:xfrm>
+          <a:prstGeom prst="roundRect">
+            <a:avLst>
+              <a:gd name="adj" fmla="val 15909"/>
+            </a:avLst>
+          </a:prstGeom>
+          <a:solidFill>
+            <a:srgbClr val="E9F5F0"/>
+          </a:solidFill>
+          <a:ln w="12700">
+            <a:solidFill>
+              <a:srgbClr val="333333"/>
+            </a:solidFill>
+            <a:prstDash val="solid"/>
+          </a:ln>
+        </p:spPr>
+      </p:sp>
+      <p:sp>
+        <p:nvSpPr>
+          <p:cNvPr id="43" name="Text 41"/>
+          <p:cNvSpPr/>
+          <p:nvPr/>
+        </p:nvSpPr>
+        <p:spPr>
+          <a:xfrm>
+            <a:off x="8432597" y="3986784"/>
+            <a:ext cx="2954426" cy="402336"/>
+          </a:xfrm>
+          <a:prstGeom prst="rect">
+            <a:avLst/>
+          </a:prstGeom>
+          <a:noFill/>
+          <a:ln/>
+        </p:spPr>
+        <p:txBody>
+          <a:bodyPr wrap="square" lIns="0" tIns="0" rIns="0" bIns="0" rtlCol="0" anchor="ctr"/>
+          <a:lstStyle/>
+          <a:p>
+            <a:pPr algn="ctr" indent="0" marL="0">
+              <a:buNone/>
+            </a:pPr>
+            <a:r>
+              <a:rPr lang="en-US" sz="950" b="1" spc="60" kern="0" dirty="0">
+                <a:solidFill>
+                  <a:srgbClr val="2E7D5B"/>
+                </a:solidFill>
+                <a:latin typeface="맑은 고딕" pitchFamily="34" charset="0"/>
+                <a:ea typeface="맑은 고딕" pitchFamily="34" charset="-122"/>
+                <a:cs typeface="맑은 고딕" pitchFamily="34" charset="-120"/>
+              </a:rPr>
+              <a:t>Section 01 근거  03</a:t>
+            </a:r>
+            <a:endParaRPr lang="en-US" sz="950" dirty="0"/>
+          </a:p>
+        </p:txBody>
+      </p:sp>
+      <p:sp>
+        <p:nvSpPr>
+          <p:cNvPr id="44" name="Shape 42"/>
+          <p:cNvSpPr/>
+          <p:nvPr/>
+        </p:nvSpPr>
+        <p:spPr>
+          <a:xfrm>
+            <a:off x="566928" y="4791456"/>
+            <a:ext cx="11057839" cy="786384"/>
+          </a:xfrm>
+          <a:prstGeom prst="roundRect">
+            <a:avLst>
+              <a:gd name="adj" fmla="val 11628"/>
+            </a:avLst>
+          </a:prstGeom>
+          <a:solidFill>
+            <a:srgbClr val="1B3A5C"/>
+          </a:solidFill>
+          <a:ln w="12700">
+            <a:solidFill>
+              <a:srgbClr val="1B3A5C"/>
+            </a:solidFill>
+            <a:prstDash val="solid"/>
+          </a:ln>
+        </p:spPr>
+      </p:sp>
+      <p:sp>
+        <p:nvSpPr>
+          <p:cNvPr id="45" name="Text 43"/>
+          <p:cNvSpPr/>
+          <p:nvPr/>
+        </p:nvSpPr>
+        <p:spPr>
+          <a:xfrm>
+            <a:off x="795528" y="4791456"/>
+            <a:ext cx="10600639" cy="786384"/>
+          </a:xfrm>
+          <a:prstGeom prst="rect">
+            <a:avLst/>
+          </a:prstGeom>
+          <a:noFill/>
+          <a:ln/>
+        </p:spPr>
+        <p:txBody>
+          <a:bodyPr wrap="square" lIns="0" tIns="0" rIns="0" bIns="0" rtlCol="0" anchor="ctr"/>
+          <a:lstStyle/>
+          <a:p>
+            <a:pPr algn="ctr" indent="0" marL="0">
+              <a:buNone/>
+            </a:pPr>
+            <a:r>
+              <a:rPr lang="en-US" sz="1700" b="1" dirty="0">
+                <a:solidFill>
+                  <a:srgbClr val="E17B34"/>
+                </a:solidFill>
+                <a:latin typeface="바탕" pitchFamily="34" charset="0"/>
+                <a:ea typeface="바탕" pitchFamily="34" charset="-122"/>
+                <a:cs typeface="바탕" pitchFamily="34" charset="-120"/>
+              </a:rPr>
+              <a:t>“ </a:t>
+            </a:r>
+            <a:pPr algn="ctr" indent="0" marL="0">
+              <a:buNone/>
+            </a:pPr>
+            <a:r>
+              <a:rPr lang="en-US" sz="1400" b="1" dirty="0">
+                <a:solidFill>
+                  <a:srgbClr val="FFFFFF"/>
+                </a:solidFill>
+                <a:latin typeface="맑은 고딕" pitchFamily="34" charset="0"/>
+                <a:ea typeface="맑은 고딕" pitchFamily="34" charset="-122"/>
+                <a:cs typeface="맑은 고딕" pitchFamily="34" charset="-120"/>
+              </a:rPr>
+              <a:t>Well-to-Wake는 규제 보고의 틀이고, Tank-to-Wake는 본선이 실제로 통제할 수 있는 구간입니다.</a:t>
+            </a:r>
+            <a:pPr algn="ctr" indent="0" marL="0">
+              <a:buNone/>
+            </a:pPr>
+            <a:r>
+              <a:rPr lang="en-US" sz="1700" b="1" dirty="0">
+                <a:solidFill>
+                  <a:srgbClr val="E17B34"/>
+                </a:solidFill>
+                <a:latin typeface="바탕" pitchFamily="34" charset="0"/>
+                <a:ea typeface="바탕" pitchFamily="34" charset="-122"/>
+                <a:cs typeface="바탕" pitchFamily="34" charset="-120"/>
+              </a:rPr>
+              <a:t> ”</a:t>
+            </a:r>
+            <a:endParaRPr lang="en-US" sz="1700" dirty="0"/>
+          </a:p>
+        </p:txBody>
+      </p:sp>
+      <p:sp>
+        <p:nvSpPr>
+          <p:cNvPr id="46" name="Text 44"/>
+          <p:cNvSpPr/>
+          <p:nvPr/>
+        </p:nvSpPr>
+        <p:spPr>
+          <a:xfrm>
+            <a:off x="566928" y="5705856"/>
+            <a:ext cx="11057839" cy="219456"/>
+          </a:xfrm>
+          <a:prstGeom prst="rect">
+            <a:avLst/>
+          </a:prstGeom>
+          <a:noFill/>
+          <a:ln/>
+        </p:spPr>
+        <p:txBody>
+          <a:bodyPr wrap="square" lIns="0" tIns="0" rIns="0" bIns="0" rtlCol="0" anchor="ctr"/>
+          <a:lstStyle/>
+          <a:p>
+            <a:pPr indent="0" marL="0">
+              <a:buNone/>
+            </a:pPr>
+            <a:r>
+              <a:rPr lang="en-US" sz="850" i="1" dirty="0">
+                <a:solidFill>
+                  <a:srgbClr val="8A94A6"/>
+                </a:solidFill>
+                <a:latin typeface="맑은 고딕" pitchFamily="34" charset="0"/>
+                <a:ea typeface="맑은 고딕" pitchFamily="34" charset="-122"/>
+                <a:cs typeface="맑은 고딕" pitchFamily="34" charset="-120"/>
+              </a:rPr>
+              <a:t>출처: Wilhelmsen Ships Service, “How holistic fuel management supports cleaner and more efficient vessel operations” (Tank to Wake)</a:t>
+            </a:r>
+            <a:endParaRPr lang="en-US" sz="850" dirty="0"/>
+          </a:p>
+        </p:txBody>
+      </p:sp>
+    </p:spTree>
+  </p:cSld>
+  <p:clrMapOvr>
+    <a:masterClrMapping/>
+  </p:clrMapOvr>
+</p:sld>
+</file>
+
+<file path=ppt/slides/slide11.xml><?xml version="1.0" encoding="utf-8"?>
+<p:sld xmlns:a="http://schemas.openxmlformats.org/drawingml/2006/main" xmlns:r="http://schemas.openxmlformats.org/officeDocument/2006/relationships" xmlns:p="http://schemas.openxmlformats.org/presentationml/2006/main">
+  <p:cSld name="Slide 11">
+    <p:bg>
+      <p:bgPr>
+        <a:solidFill>
+          <a:srgbClr val="F4F6FB"/>
+        </a:solidFill>
+      </p:bgPr>
+    </p:bg>
+    <p:spTree>
+      <p:nvGrpSpPr>
+        <p:cNvPr id="1" name=""/>
+        <p:cNvGrpSpPr/>
+        <p:nvPr/>
+      </p:nvGrpSpPr>
+      <p:grpSpPr>
+        <a:xfrm>
+          <a:off x="0" y="0"/>
+          <a:ext cx="0" cy="0"/>
+          <a:chOff x="0" y="0"/>
+          <a:chExt cx="0" cy="0"/>
+        </a:xfrm>
+      </p:grpSpPr>
+      <p:sp>
+        <p:nvSpPr>
+          <p:cNvPr id="2" name="Text 0"/>
+          <p:cNvSpPr/>
+          <p:nvPr/>
+        </p:nvSpPr>
+        <p:spPr>
+          <a:xfrm>
+            <a:off x="566928" y="402336"/>
+            <a:ext cx="7315200" cy="256032"/>
+          </a:xfrm>
+          <a:prstGeom prst="rect">
+            <a:avLst/>
+          </a:prstGeom>
+          <a:noFill/>
+          <a:ln/>
+        </p:spPr>
+        <p:txBody>
+          <a:bodyPr wrap="square" lIns="0" tIns="0" rIns="0" bIns="0" rtlCol="0" anchor="ctr"/>
+          <a:lstStyle/>
+          <a:p>
+            <a:pPr algn="l" indent="0" marL="0">
+              <a:buNone/>
+            </a:pPr>
+            <a:r>
+              <a:rPr lang="en-US" sz="1150" b="1" spc="240" kern="0" dirty="0">
+                <a:solidFill>
+                  <a:srgbClr val="E17B34"/>
+                </a:solidFill>
+                <a:latin typeface="맑은 고딕" pitchFamily="34" charset="0"/>
+                <a:ea typeface="맑은 고딕" pitchFamily="34" charset="-122"/>
+                <a:cs typeface="맑은 고딕" pitchFamily="34" charset="-120"/>
+              </a:rPr>
+              <a:t>10   결론</a:t>
+            </a:r>
+            <a:endParaRPr lang="en-US" sz="1150" dirty="0"/>
+          </a:p>
+        </p:txBody>
+      </p:sp>
+      <p:sp>
+        <p:nvSpPr>
+          <p:cNvPr id="3" name="Text 1"/>
+          <p:cNvSpPr/>
+          <p:nvPr/>
+        </p:nvSpPr>
+        <p:spPr>
+          <a:xfrm>
+            <a:off x="566928" y="694944"/>
+            <a:ext cx="11057839" cy="713232"/>
+          </a:xfrm>
+          <a:prstGeom prst="rect">
+            <a:avLst/>
+          </a:prstGeom>
+          <a:noFill/>
+          <a:ln/>
+        </p:spPr>
+        <p:txBody>
+          <a:bodyPr wrap="square" lIns="0" tIns="0" rIns="0" bIns="0" rtlCol="0" anchor="ctr"/>
+          <a:lstStyle/>
+          <a:p>
+            <a:pPr algn="l" indent="0" marL="0">
+              <a:buNone/>
+            </a:pPr>
+            <a:r>
+              <a:rPr lang="en-US" sz="3600" dirty="0">
+                <a:solidFill>
+                  <a:srgbClr val="1B3A5C"/>
+                </a:solidFill>
+                <a:latin typeface="바탕" pitchFamily="34" charset="0"/>
+                <a:ea typeface="바탕" pitchFamily="34" charset="-122"/>
+                <a:cs typeface="바탕" pitchFamily="34" charset="-120"/>
+              </a:rPr>
+              <a:t>손실은 단계마다 쌓입니다</a:t>
+            </a:r>
+            <a:endParaRPr lang="en-US" sz="3600" dirty="0"/>
+          </a:p>
+        </p:txBody>
+      </p:sp>
+      <p:sp>
+        <p:nvSpPr>
+          <p:cNvPr id="4" name="Text 2"/>
+          <p:cNvSpPr/>
+          <p:nvPr/>
+        </p:nvSpPr>
+        <p:spPr>
+          <a:xfrm>
+            <a:off x="566928" y="6419088"/>
+            <a:ext cx="8778240" cy="274320"/>
+          </a:xfrm>
+          <a:prstGeom prst="rect">
+            <a:avLst/>
+          </a:prstGeom>
+          <a:noFill/>
+          <a:ln/>
+        </p:spPr>
+        <p:txBody>
+          <a:bodyPr wrap="square" lIns="0" tIns="0" rIns="0" bIns="0" rtlCol="0" anchor="ctr"/>
+          <a:lstStyle/>
+          <a:p>
+            <a:pPr indent="0" marL="0">
+              <a:buNone/>
+            </a:pPr>
+            <a:r>
+              <a:rPr lang="en-US" sz="850" dirty="0">
+                <a:solidFill>
+                  <a:srgbClr val="8A94A6"/>
+                </a:solidFill>
+                <a:latin typeface="맑은 고딕" pitchFamily="34" charset="0"/>
+                <a:ea typeface="맑은 고딕" pitchFamily="34" charset="-122"/>
+                <a:cs typeface="맑은 고딕" pitchFamily="34" charset="-120"/>
+              </a:rPr>
+              <a:t>Classified as Internal - This content is proprietary information intended for employees and partners only.</a:t>
+            </a:r>
+            <a:endParaRPr lang="en-US" sz="850" dirty="0"/>
+          </a:p>
+        </p:txBody>
+      </p:sp>
+      <p:sp>
+        <p:nvSpPr>
+          <p:cNvPr id="5" name="Text 3"/>
+          <p:cNvSpPr/>
+          <p:nvPr/>
+        </p:nvSpPr>
+        <p:spPr>
+          <a:xfrm>
+            <a:off x="11155680" y="6419088"/>
+            <a:ext cx="502920" cy="274320"/>
+          </a:xfrm>
+          <a:prstGeom prst="rect">
+            <a:avLst/>
+          </a:prstGeom>
+          <a:noFill/>
+          <a:ln/>
+        </p:spPr>
+        <p:txBody>
+          <a:bodyPr wrap="square" lIns="0" tIns="0" rIns="0" bIns="0" rtlCol="0" anchor="ctr"/>
+          <a:lstStyle/>
+          <a:p>
+            <a:pPr algn="r" indent="0" marL="0">
+              <a:buNone/>
+            </a:pPr>
+            <a:r>
+              <a:rPr lang="en-US" sz="950" dirty="0">
+                <a:solidFill>
+                  <a:srgbClr val="8A94A6"/>
+                </a:solidFill>
+                <a:latin typeface="맑은 고딕" pitchFamily="34" charset="0"/>
+                <a:ea typeface="맑은 고딕" pitchFamily="34" charset="-122"/>
+                <a:cs typeface="맑은 고딕" pitchFamily="34" charset="-120"/>
+              </a:rPr>
+              <a:t>11</a:t>
+            </a:r>
+            <a:endParaRPr lang="en-US" sz="950" dirty="0"/>
+          </a:p>
+        </p:txBody>
+      </p:sp>
+      <p:sp>
+        <p:nvSpPr>
+          <p:cNvPr id="6" name="Shape 4"/>
+          <p:cNvSpPr/>
+          <p:nvPr/>
+        </p:nvSpPr>
+        <p:spPr>
+          <a:xfrm>
+            <a:off x="566928" y="1591056"/>
+            <a:ext cx="2421560" cy="1481328"/>
+          </a:xfrm>
+          <a:prstGeom prst="roundRect">
+            <a:avLst>
+              <a:gd name="adj" fmla="val 8642"/>
+            </a:avLst>
+          </a:prstGeom>
+          <a:solidFill>
+            <a:srgbClr val="FFFFFF"/>
+          </a:solidFill>
+          <a:ln w="9525">
+            <a:solidFill>
+              <a:srgbClr val="EDF1F8"/>
+            </a:solidFill>
+            <a:prstDash val="solid"/>
+          </a:ln>
+          <a:effectLst>
+            <a:outerShdw sx="100000" sy="100000" kx="0" ky="0" algn="bl" rotWithShape="0" blurRad="127000" dist="25400" dir="5400000">
+              <a:srgbClr val="9BAAC4">
+                <a:alpha val="22000"/>
+              </a:srgbClr>
+            </a:outerShdw>
+          </a:effectLst>
+        </p:spPr>
+      </p:sp>
+      <p:sp>
+        <p:nvSpPr>
+          <p:cNvPr id="7" name="Shape 5"/>
+          <p:cNvSpPr/>
+          <p:nvPr/>
+        </p:nvSpPr>
+        <p:spPr>
+          <a:xfrm>
+            <a:off x="804672" y="1773936"/>
+            <a:ext cx="310896" cy="310896"/>
+          </a:xfrm>
+          <a:prstGeom prst="roundRect">
+            <a:avLst>
+              <a:gd name="adj" fmla="val 50000"/>
+            </a:avLst>
+          </a:prstGeom>
+          <a:solidFill>
+            <a:srgbClr val="2E5C8A"/>
+          </a:solidFill>
+          <a:ln w="12700">
+            <a:solidFill>
+              <a:srgbClr val="333333"/>
+            </a:solidFill>
+            <a:prstDash val="solid"/>
+          </a:ln>
+        </p:spPr>
+      </p:sp>
+      <p:sp>
+        <p:nvSpPr>
+          <p:cNvPr id="8" name="Text 6"/>
+          <p:cNvSpPr/>
+          <p:nvPr/>
+        </p:nvSpPr>
+        <p:spPr>
+          <a:xfrm>
+            <a:off x="804672" y="1773936"/>
+            <a:ext cx="310896" cy="310896"/>
+          </a:xfrm>
+          <a:prstGeom prst="rect">
+            <a:avLst/>
+          </a:prstGeom>
+          <a:noFill/>
+          <a:ln/>
+        </p:spPr>
+        <p:txBody>
+          <a:bodyPr wrap="square" lIns="0" tIns="0" rIns="0" bIns="0" rtlCol="0" anchor="ctr"/>
+          <a:lstStyle/>
+          <a:p>
+            <a:pPr algn="ctr" indent="0" marL="0">
+              <a:buNone/>
+            </a:pPr>
+            <a:r>
+              <a:rPr lang="en-US" sz="1100" b="1" dirty="0">
+                <a:solidFill>
+                  <a:srgbClr val="FFFFFF"/>
+                </a:solidFill>
+                <a:latin typeface="맑은 고딕" pitchFamily="34" charset="0"/>
+                <a:ea typeface="맑은 고딕" pitchFamily="34" charset="-122"/>
+                <a:cs typeface="맑은 고딕" pitchFamily="34" charset="-120"/>
+              </a:rPr>
+              <a:t>1</a:t>
+            </a:r>
+            <a:endParaRPr lang="en-US" sz="1100" dirty="0"/>
+          </a:p>
+        </p:txBody>
+      </p:sp>
+      <p:sp>
+        <p:nvSpPr>
+          <p:cNvPr id="9" name="Text 7"/>
+          <p:cNvSpPr/>
+          <p:nvPr/>
+        </p:nvSpPr>
+        <p:spPr>
+          <a:xfrm>
+            <a:off x="1207008" y="1773936"/>
+            <a:ext cx="1543736" cy="310896"/>
+          </a:xfrm>
+          <a:prstGeom prst="rect">
+            <a:avLst/>
+          </a:prstGeom>
+          <a:noFill/>
+          <a:ln/>
+        </p:spPr>
+        <p:txBody>
+          <a:bodyPr wrap="square" lIns="0" tIns="0" rIns="0" bIns="0" rtlCol="0" anchor="ctr"/>
+          <a:lstStyle/>
+          <a:p>
+            <a:pPr indent="0" marL="0">
+              <a:buNone/>
+            </a:pPr>
+            <a:r>
+              <a:rPr lang="en-US" sz="1250" b="1" dirty="0">
+                <a:solidFill>
+                  <a:srgbClr val="1B3A5C"/>
+                </a:solidFill>
+                <a:latin typeface="맑은 고딕" pitchFamily="34" charset="0"/>
+                <a:ea typeface="맑은 고딕" pitchFamily="34" charset="-122"/>
+                <a:cs typeface="맑은 고딕" pitchFamily="34" charset="-120"/>
+              </a:rPr>
+              <a:t>저장 중 열화</a:t>
+            </a:r>
+            <a:endParaRPr lang="en-US" sz="1250" dirty="0"/>
+          </a:p>
+        </p:txBody>
+      </p:sp>
+      <p:sp>
+        <p:nvSpPr>
+          <p:cNvPr id="10" name="Text 8"/>
+          <p:cNvSpPr/>
+          <p:nvPr/>
+        </p:nvSpPr>
+        <p:spPr>
+          <a:xfrm>
+            <a:off x="804672" y="2194560"/>
+            <a:ext cx="1946072" cy="694944"/>
+          </a:xfrm>
+          <a:prstGeom prst="rect">
+            <a:avLst/>
+          </a:prstGeom>
+          <a:noFill/>
+          <a:ln/>
+        </p:spPr>
+        <p:txBody>
+          <a:bodyPr wrap="square" lIns="0" tIns="0" rIns="0" bIns="0" rtlCol="0" anchor="t"/>
+          <a:lstStyle/>
+          <a:p>
+            <a:pPr indent="0" marL="0">
+              <a:lnSpc>
+                <a:spcPts val="1500"/>
+              </a:lnSpc>
+              <a:buNone/>
+            </a:pPr>
+            <a:r>
+              <a:rPr lang="en-US" sz="1050" dirty="0">
+                <a:solidFill>
+                  <a:srgbClr val="3D4A5C"/>
+                </a:solidFill>
+                <a:latin typeface="맑은 고딕" pitchFamily="34" charset="0"/>
+                <a:ea typeface="맑은 고딕" pitchFamily="34" charset="-122"/>
+                <a:cs typeface="맑은 고딕" pitchFamily="34" charset="-120"/>
+              </a:rPr>
+              <a:t>연료가 탱크 안에서</a:t>
+            </a:r>
+            <a:endParaRPr lang="en-US" sz="1050" dirty="0"/>
+          </a:p>
+          <a:p>
+            <a:pPr indent="0" marL="0">
+              <a:lnSpc>
+                <a:spcPts val="1500"/>
+              </a:lnSpc>
+              <a:buNone/>
+            </a:pPr>
+            <a:r>
+              <a:rPr lang="en-US" sz="1050" dirty="0">
+                <a:solidFill>
+                  <a:srgbClr val="3D4A5C"/>
+                </a:solidFill>
+                <a:latin typeface="맑은 고딕" pitchFamily="34" charset="0"/>
+                <a:ea typeface="맑은 고딕" pitchFamily="34" charset="-122"/>
+                <a:cs typeface="맑은 고딕" pitchFamily="34" charset="-120"/>
+              </a:rPr>
+              <a:t>계속 변합니다</a:t>
+            </a:r>
+            <a:endParaRPr lang="en-US" sz="1050" dirty="0"/>
+          </a:p>
+        </p:txBody>
+      </p:sp>
+      <p:sp>
+        <p:nvSpPr>
+          <p:cNvPr id="11" name="Text 9"/>
+          <p:cNvSpPr/>
+          <p:nvPr/>
+        </p:nvSpPr>
+        <p:spPr>
+          <a:xfrm>
+            <a:off x="3034208" y="2148840"/>
+            <a:ext cx="365760" cy="365760"/>
+          </a:xfrm>
+          <a:prstGeom prst="rect">
+            <a:avLst/>
+          </a:prstGeom>
+          <a:noFill/>
+          <a:ln/>
+        </p:spPr>
+        <p:txBody>
+          <a:bodyPr wrap="square" lIns="0" tIns="0" rIns="0" bIns="0" rtlCol="0" anchor="ctr"/>
+          <a:lstStyle/>
+          <a:p>
+            <a:pPr algn="ctr" indent="0" marL="0">
+              <a:buNone/>
+            </a:pPr>
+            <a:r>
+              <a:rPr lang="en-US" sz="1300" dirty="0">
+                <a:solidFill>
+                  <a:srgbClr val="B9C4D6"/>
+                </a:solidFill>
+                <a:latin typeface="맑은 고딕" pitchFamily="34" charset="0"/>
+                <a:ea typeface="맑은 고딕" pitchFamily="34" charset="-122"/>
+                <a:cs typeface="맑은 고딕" pitchFamily="34" charset="-120"/>
+              </a:rPr>
+              <a:t>▶</a:t>
+            </a:r>
+            <a:endParaRPr lang="en-US" sz="1300" dirty="0"/>
+          </a:p>
+        </p:txBody>
+      </p:sp>
+      <p:sp>
+        <p:nvSpPr>
+          <p:cNvPr id="12" name="Shape 10"/>
+          <p:cNvSpPr/>
+          <p:nvPr/>
+        </p:nvSpPr>
+        <p:spPr>
+          <a:xfrm>
+            <a:off x="3445688" y="1591056"/>
+            <a:ext cx="2421560" cy="1481328"/>
+          </a:xfrm>
+          <a:prstGeom prst="roundRect">
+            <a:avLst>
+              <a:gd name="adj" fmla="val 8642"/>
+            </a:avLst>
+          </a:prstGeom>
+          <a:solidFill>
+            <a:srgbClr val="FFFFFF"/>
+          </a:solidFill>
+          <a:ln w="9525">
+            <a:solidFill>
+              <a:srgbClr val="EDF1F8"/>
+            </a:solidFill>
+            <a:prstDash val="solid"/>
+          </a:ln>
+          <a:effectLst>
+            <a:outerShdw sx="100000" sy="100000" kx="0" ky="0" algn="bl" rotWithShape="0" blurRad="127000" dist="25400" dir="5400000">
+              <a:srgbClr val="9BAAC4">
+                <a:alpha val="22000"/>
+              </a:srgbClr>
+            </a:outerShdw>
+          </a:effectLst>
+        </p:spPr>
+      </p:sp>
+      <p:sp>
+        <p:nvSpPr>
+          <p:cNvPr id="13" name="Shape 11"/>
+          <p:cNvSpPr/>
+          <p:nvPr/>
+        </p:nvSpPr>
+        <p:spPr>
+          <a:xfrm>
+            <a:off x="3683432" y="1773936"/>
+            <a:ext cx="310896" cy="310896"/>
+          </a:xfrm>
+          <a:prstGeom prst="roundRect">
+            <a:avLst>
+              <a:gd name="adj" fmla="val 50000"/>
+            </a:avLst>
+          </a:prstGeom>
+          <a:solidFill>
+            <a:srgbClr val="6E93BF"/>
+          </a:solidFill>
+          <a:ln w="12700">
+            <a:solidFill>
+              <a:srgbClr val="333333"/>
+            </a:solidFill>
+            <a:prstDash val="solid"/>
+          </a:ln>
+        </p:spPr>
+      </p:sp>
+      <p:sp>
+        <p:nvSpPr>
+          <p:cNvPr id="14" name="Text 12"/>
+          <p:cNvSpPr/>
+          <p:nvPr/>
+        </p:nvSpPr>
+        <p:spPr>
+          <a:xfrm>
+            <a:off x="3683432" y="1773936"/>
+            <a:ext cx="310896" cy="310896"/>
+          </a:xfrm>
+          <a:prstGeom prst="rect">
+            <a:avLst/>
+          </a:prstGeom>
+          <a:noFill/>
+          <a:ln/>
+        </p:spPr>
+        <p:txBody>
+          <a:bodyPr wrap="square" lIns="0" tIns="0" rIns="0" bIns="0" rtlCol="0" anchor="ctr"/>
+          <a:lstStyle/>
+          <a:p>
+            <a:pPr algn="ctr" indent="0" marL="0">
+              <a:buNone/>
+            </a:pPr>
+            <a:r>
+              <a:rPr lang="en-US" sz="1100" b="1" dirty="0">
+                <a:solidFill>
+                  <a:srgbClr val="FFFFFF"/>
+                </a:solidFill>
+                <a:latin typeface="맑은 고딕" pitchFamily="34" charset="0"/>
+                <a:ea typeface="맑은 고딕" pitchFamily="34" charset="-122"/>
+                <a:cs typeface="맑은 고딕" pitchFamily="34" charset="-120"/>
+              </a:rPr>
+              <a:t>2</a:t>
+            </a:r>
+            <a:endParaRPr lang="en-US" sz="1100" dirty="0"/>
+          </a:p>
+        </p:txBody>
+      </p:sp>
+      <p:sp>
+        <p:nvSpPr>
+          <p:cNvPr id="15" name="Text 13"/>
+          <p:cNvSpPr/>
+          <p:nvPr/>
+        </p:nvSpPr>
+        <p:spPr>
+          <a:xfrm>
+            <a:off x="4085768" y="1773936"/>
+            <a:ext cx="1543736" cy="310896"/>
+          </a:xfrm>
+          <a:prstGeom prst="rect">
+            <a:avLst/>
+          </a:prstGeom>
+          <a:noFill/>
+          <a:ln/>
+        </p:spPr>
+        <p:txBody>
+          <a:bodyPr wrap="square" lIns="0" tIns="0" rIns="0" bIns="0" rtlCol="0" anchor="ctr"/>
+          <a:lstStyle/>
+          <a:p>
+            <a:pPr indent="0" marL="0">
+              <a:buNone/>
+            </a:pPr>
+            <a:r>
+              <a:rPr lang="en-US" sz="1250" b="1" dirty="0">
+                <a:solidFill>
+                  <a:srgbClr val="1B3A5C"/>
+                </a:solidFill>
+                <a:latin typeface="맑은 고딕" pitchFamily="34" charset="0"/>
+                <a:ea typeface="맑은 고딕" pitchFamily="34" charset="-122"/>
+                <a:cs typeface="맑은 고딕" pitchFamily="34" charset="-120"/>
+              </a:rPr>
+              <a:t>슬러지 발생</a:t>
+            </a:r>
+            <a:endParaRPr lang="en-US" sz="1250" dirty="0"/>
+          </a:p>
+        </p:txBody>
+      </p:sp>
+      <p:sp>
+        <p:nvSpPr>
+          <p:cNvPr id="16" name="Text 14"/>
+          <p:cNvSpPr/>
+          <p:nvPr/>
+        </p:nvSpPr>
+        <p:spPr>
+          <a:xfrm>
+            <a:off x="3683432" y="2194560"/>
+            <a:ext cx="1946072" cy="694944"/>
+          </a:xfrm>
+          <a:prstGeom prst="rect">
+            <a:avLst/>
+          </a:prstGeom>
+          <a:noFill/>
+          <a:ln/>
+        </p:spPr>
+        <p:txBody>
+          <a:bodyPr wrap="square" lIns="0" tIns="0" rIns="0" bIns="0" rtlCol="0" anchor="t"/>
+          <a:lstStyle/>
+          <a:p>
+            <a:pPr indent="0" marL="0">
+              <a:lnSpc>
+                <a:spcPts val="1500"/>
+              </a:lnSpc>
+              <a:buNone/>
+            </a:pPr>
+            <a:r>
+              <a:rPr lang="en-US" sz="1050" dirty="0">
+                <a:solidFill>
+                  <a:srgbClr val="3D4A5C"/>
+                </a:solidFill>
+                <a:latin typeface="맑은 고딕" pitchFamily="34" charset="0"/>
+                <a:ea typeface="맑은 고딕" pitchFamily="34" charset="-122"/>
+                <a:cs typeface="맑은 고딕" pitchFamily="34" charset="-120"/>
+              </a:rPr>
+              <a:t>엔진에 도달하지 못한 연료</a:t>
+            </a:r>
+            <a:endParaRPr lang="en-US" sz="1050" dirty="0"/>
+          </a:p>
+          <a:p>
+            <a:pPr indent="0" marL="0">
+              <a:lnSpc>
+                <a:spcPts val="1500"/>
+              </a:lnSpc>
+              <a:buNone/>
+            </a:pPr>
+            <a:r>
+              <a:rPr lang="en-US" sz="1050" dirty="0">
+                <a:solidFill>
+                  <a:srgbClr val="3D4A5C"/>
+                </a:solidFill>
+                <a:latin typeface="맑은 고딕" pitchFamily="34" charset="0"/>
+                <a:ea typeface="맑은 고딕" pitchFamily="34" charset="-122"/>
+                <a:cs typeface="맑은 고딕" pitchFamily="34" charset="-120"/>
+              </a:rPr>
+              <a:t>— 손실 확정</a:t>
+            </a:r>
+            <a:endParaRPr lang="en-US" sz="1050" dirty="0"/>
+          </a:p>
+        </p:txBody>
+      </p:sp>
+      <p:sp>
+        <p:nvSpPr>
+          <p:cNvPr id="17" name="Text 15"/>
+          <p:cNvSpPr/>
+          <p:nvPr/>
+        </p:nvSpPr>
+        <p:spPr>
+          <a:xfrm>
+            <a:off x="5912968" y="2148840"/>
+            <a:ext cx="365760" cy="365760"/>
+          </a:xfrm>
+          <a:prstGeom prst="rect">
+            <a:avLst/>
+          </a:prstGeom>
+          <a:noFill/>
+          <a:ln/>
+        </p:spPr>
+        <p:txBody>
+          <a:bodyPr wrap="square" lIns="0" tIns="0" rIns="0" bIns="0" rtlCol="0" anchor="ctr"/>
+          <a:lstStyle/>
+          <a:p>
+            <a:pPr algn="ctr" indent="0" marL="0">
+              <a:buNone/>
+            </a:pPr>
+            <a:r>
+              <a:rPr lang="en-US" sz="1300" dirty="0">
+                <a:solidFill>
+                  <a:srgbClr val="B9C4D6"/>
+                </a:solidFill>
+                <a:latin typeface="맑은 고딕" pitchFamily="34" charset="0"/>
+                <a:ea typeface="맑은 고딕" pitchFamily="34" charset="-122"/>
+                <a:cs typeface="맑은 고딕" pitchFamily="34" charset="-120"/>
+              </a:rPr>
+              <a:t>▶</a:t>
+            </a:r>
+            <a:endParaRPr lang="en-US" sz="1300" dirty="0"/>
+          </a:p>
+        </p:txBody>
+      </p:sp>
+      <p:sp>
+        <p:nvSpPr>
+          <p:cNvPr id="18" name="Shape 16"/>
+          <p:cNvSpPr/>
+          <p:nvPr/>
+        </p:nvSpPr>
+        <p:spPr>
+          <a:xfrm>
+            <a:off x="6324448" y="1591056"/>
+            <a:ext cx="2421560" cy="1481328"/>
+          </a:xfrm>
+          <a:prstGeom prst="roundRect">
+            <a:avLst>
+              <a:gd name="adj" fmla="val 8642"/>
+            </a:avLst>
+          </a:prstGeom>
+          <a:solidFill>
+            <a:srgbClr val="FFFFFF"/>
+          </a:solidFill>
+          <a:ln w="9525">
+            <a:solidFill>
+              <a:srgbClr val="EDF1F8"/>
+            </a:solidFill>
+            <a:prstDash val="solid"/>
+          </a:ln>
+          <a:effectLst>
+            <a:outerShdw sx="100000" sy="100000" kx="0" ky="0" algn="bl" rotWithShape="0" blurRad="127000" dist="25400" dir="5400000">
+              <a:srgbClr val="9BAAC4">
+                <a:alpha val="22000"/>
+              </a:srgbClr>
+            </a:outerShdw>
+          </a:effectLst>
+        </p:spPr>
+      </p:sp>
+      <p:sp>
+        <p:nvSpPr>
+          <p:cNvPr id="19" name="Shape 17"/>
+          <p:cNvSpPr/>
+          <p:nvPr/>
+        </p:nvSpPr>
+        <p:spPr>
+          <a:xfrm>
+            <a:off x="6562192" y="1773936"/>
+            <a:ext cx="310896" cy="310896"/>
+          </a:xfrm>
+          <a:prstGeom prst="roundRect">
+            <a:avLst>
+              <a:gd name="adj" fmla="val 50000"/>
+            </a:avLst>
+          </a:prstGeom>
+          <a:solidFill>
+            <a:srgbClr val="E17B34"/>
+          </a:solidFill>
+          <a:ln w="12700">
+            <a:solidFill>
+              <a:srgbClr val="333333"/>
+            </a:solidFill>
+            <a:prstDash val="solid"/>
+          </a:ln>
+        </p:spPr>
+      </p:sp>
+      <p:sp>
+        <p:nvSpPr>
+          <p:cNvPr id="20" name="Text 18"/>
+          <p:cNvSpPr/>
+          <p:nvPr/>
+        </p:nvSpPr>
+        <p:spPr>
+          <a:xfrm>
+            <a:off x="6562192" y="1773936"/>
+            <a:ext cx="310896" cy="310896"/>
+          </a:xfrm>
+          <a:prstGeom prst="rect">
+            <a:avLst/>
+          </a:prstGeom>
+          <a:noFill/>
+          <a:ln/>
+        </p:spPr>
+        <p:txBody>
+          <a:bodyPr wrap="square" lIns="0" tIns="0" rIns="0" bIns="0" rtlCol="0" anchor="ctr"/>
+          <a:lstStyle/>
+          <a:p>
+            <a:pPr algn="ctr" indent="0" marL="0">
+              <a:buNone/>
+            </a:pPr>
+            <a:r>
+              <a:rPr lang="en-US" sz="1100" b="1" dirty="0">
+                <a:solidFill>
+                  <a:srgbClr val="FFFFFF"/>
+                </a:solidFill>
+                <a:latin typeface="맑은 고딕" pitchFamily="34" charset="0"/>
+                <a:ea typeface="맑은 고딕" pitchFamily="34" charset="-122"/>
+                <a:cs typeface="맑은 고딕" pitchFamily="34" charset="-120"/>
+              </a:rPr>
+              <a:t>3</a:t>
+            </a:r>
+            <a:endParaRPr lang="en-US" sz="1100" dirty="0"/>
+          </a:p>
+        </p:txBody>
+      </p:sp>
+      <p:sp>
+        <p:nvSpPr>
+          <p:cNvPr id="21" name="Text 19"/>
+          <p:cNvSpPr/>
+          <p:nvPr/>
+        </p:nvSpPr>
+        <p:spPr>
+          <a:xfrm>
+            <a:off x="6964528" y="1773936"/>
+            <a:ext cx="1543736" cy="310896"/>
+          </a:xfrm>
+          <a:prstGeom prst="rect">
+            <a:avLst/>
+          </a:prstGeom>
+          <a:noFill/>
+          <a:ln/>
+        </p:spPr>
+        <p:txBody>
+          <a:bodyPr wrap="square" lIns="0" tIns="0" rIns="0" bIns="0" rtlCol="0" anchor="ctr"/>
+          <a:lstStyle/>
+          <a:p>
+            <a:pPr indent="0" marL="0">
+              <a:buNone/>
+            </a:pPr>
+            <a:r>
+              <a:rPr lang="en-US" sz="1250" b="1" dirty="0">
+                <a:solidFill>
+                  <a:srgbClr val="1B3A5C"/>
+                </a:solidFill>
+                <a:latin typeface="맑은 고딕" pitchFamily="34" charset="0"/>
+                <a:ea typeface="맑은 고딕" pitchFamily="34" charset="-122"/>
+                <a:cs typeface="맑은 고딕" pitchFamily="34" charset="-120"/>
+              </a:rPr>
+              <a:t>연소 품질 저하</a:t>
+            </a:r>
+            <a:endParaRPr lang="en-US" sz="1250" dirty="0"/>
+          </a:p>
+        </p:txBody>
+      </p:sp>
+      <p:sp>
+        <p:nvSpPr>
+          <p:cNvPr id="22" name="Text 20"/>
+          <p:cNvSpPr/>
+          <p:nvPr/>
+        </p:nvSpPr>
+        <p:spPr>
+          <a:xfrm>
+            <a:off x="6562192" y="2194560"/>
+            <a:ext cx="1946072" cy="694944"/>
+          </a:xfrm>
+          <a:prstGeom prst="rect">
+            <a:avLst/>
+          </a:prstGeom>
+          <a:noFill/>
+          <a:ln/>
+        </p:spPr>
+        <p:txBody>
+          <a:bodyPr wrap="square" lIns="0" tIns="0" rIns="0" bIns="0" rtlCol="0" anchor="t"/>
+          <a:lstStyle/>
+          <a:p>
+            <a:pPr indent="0" marL="0">
+              <a:lnSpc>
+                <a:spcPts val="1500"/>
+              </a:lnSpc>
+              <a:buNone/>
+            </a:pPr>
+            <a:r>
+              <a:rPr lang="en-US" sz="1050" dirty="0">
+                <a:solidFill>
+                  <a:srgbClr val="3D4A5C"/>
+                </a:solidFill>
+                <a:latin typeface="맑은 고딕" pitchFamily="34" charset="0"/>
+                <a:ea typeface="맑은 고딕" pitchFamily="34" charset="-122"/>
+                <a:cs typeface="맑은 고딕" pitchFamily="34" charset="-120"/>
+              </a:rPr>
+              <a:t>착화 불량 · 매연 증가</a:t>
+            </a:r>
+            <a:endParaRPr lang="en-US" sz="1050" dirty="0"/>
+          </a:p>
+        </p:txBody>
+      </p:sp>
+      <p:sp>
+        <p:nvSpPr>
+          <p:cNvPr id="23" name="Text 21"/>
+          <p:cNvSpPr/>
+          <p:nvPr/>
+        </p:nvSpPr>
+        <p:spPr>
+          <a:xfrm>
+            <a:off x="8791727" y="2148840"/>
+            <a:ext cx="365760" cy="365760"/>
+          </a:xfrm>
+          <a:prstGeom prst="rect">
+            <a:avLst/>
+          </a:prstGeom>
+          <a:noFill/>
+          <a:ln/>
+        </p:spPr>
+        <p:txBody>
+          <a:bodyPr wrap="square" lIns="0" tIns="0" rIns="0" bIns="0" rtlCol="0" anchor="ctr"/>
+          <a:lstStyle/>
+          <a:p>
+            <a:pPr algn="ctr" indent="0" marL="0">
+              <a:buNone/>
+            </a:pPr>
+            <a:r>
+              <a:rPr lang="en-US" sz="1300" dirty="0">
+                <a:solidFill>
+                  <a:srgbClr val="B9C4D6"/>
+                </a:solidFill>
+                <a:latin typeface="맑은 고딕" pitchFamily="34" charset="0"/>
+                <a:ea typeface="맑은 고딕" pitchFamily="34" charset="-122"/>
+                <a:cs typeface="맑은 고딕" pitchFamily="34" charset="-120"/>
+              </a:rPr>
+              <a:t>▶</a:t>
+            </a:r>
+            <a:endParaRPr lang="en-US" sz="1300" dirty="0"/>
+          </a:p>
+        </p:txBody>
+      </p:sp>
+      <p:sp>
+        <p:nvSpPr>
+          <p:cNvPr id="24" name="Shape 22"/>
+          <p:cNvSpPr/>
+          <p:nvPr/>
+        </p:nvSpPr>
+        <p:spPr>
+          <a:xfrm>
+            <a:off x="9203207" y="1591056"/>
+            <a:ext cx="2421560" cy="1481328"/>
+          </a:xfrm>
+          <a:prstGeom prst="roundRect">
+            <a:avLst>
+              <a:gd name="adj" fmla="val 8642"/>
+            </a:avLst>
+          </a:prstGeom>
+          <a:solidFill>
+            <a:srgbClr val="FFFFFF"/>
+          </a:solidFill>
+          <a:ln w="9525">
+            <a:solidFill>
+              <a:srgbClr val="EDF1F8"/>
+            </a:solidFill>
+            <a:prstDash val="solid"/>
+          </a:ln>
+          <a:effectLst>
+            <a:outerShdw sx="100000" sy="100000" kx="0" ky="0" algn="bl" rotWithShape="0" blurRad="127000" dist="25400" dir="5400000">
+              <a:srgbClr val="9BAAC4">
+                <a:alpha val="22000"/>
+              </a:srgbClr>
+            </a:outerShdw>
+          </a:effectLst>
+        </p:spPr>
+      </p:sp>
+      <p:sp>
+        <p:nvSpPr>
+          <p:cNvPr id="25" name="Shape 23"/>
+          <p:cNvSpPr/>
+          <p:nvPr/>
+        </p:nvSpPr>
+        <p:spPr>
+          <a:xfrm>
+            <a:off x="9440951" y="1773936"/>
+            <a:ext cx="310896" cy="310896"/>
+          </a:xfrm>
+          <a:prstGeom prst="roundRect">
+            <a:avLst>
+              <a:gd name="adj" fmla="val 50000"/>
+            </a:avLst>
+          </a:prstGeom>
+          <a:solidFill>
+            <a:srgbClr val="C0392B"/>
+          </a:solidFill>
+          <a:ln w="12700">
+            <a:solidFill>
+              <a:srgbClr val="333333"/>
+            </a:solidFill>
+            <a:prstDash val="solid"/>
+          </a:ln>
+        </p:spPr>
+      </p:sp>
+      <p:sp>
+        <p:nvSpPr>
+          <p:cNvPr id="26" name="Text 24"/>
+          <p:cNvSpPr/>
+          <p:nvPr/>
+        </p:nvSpPr>
+        <p:spPr>
+          <a:xfrm>
+            <a:off x="9440951" y="1773936"/>
+            <a:ext cx="310896" cy="310896"/>
+          </a:xfrm>
+          <a:prstGeom prst="rect">
+            <a:avLst/>
+          </a:prstGeom>
+          <a:noFill/>
+          <a:ln/>
+        </p:spPr>
+        <p:txBody>
+          <a:bodyPr wrap="square" lIns="0" tIns="0" rIns="0" bIns="0" rtlCol="0" anchor="ctr"/>
+          <a:lstStyle/>
+          <a:p>
+            <a:pPr algn="ctr" indent="0" marL="0">
+              <a:buNone/>
+            </a:pPr>
+            <a:r>
+              <a:rPr lang="en-US" sz="1100" b="1" dirty="0">
+                <a:solidFill>
+                  <a:srgbClr val="FFFFFF"/>
+                </a:solidFill>
+                <a:latin typeface="맑은 고딕" pitchFamily="34" charset="0"/>
+                <a:ea typeface="맑은 고딕" pitchFamily="34" charset="-122"/>
+                <a:cs typeface="맑은 고딕" pitchFamily="34" charset="-120"/>
+              </a:rPr>
+              <a:t>4</a:t>
+            </a:r>
+            <a:endParaRPr lang="en-US" sz="1100" dirty="0"/>
+          </a:p>
+        </p:txBody>
+      </p:sp>
+      <p:sp>
+        <p:nvSpPr>
+          <p:cNvPr id="27" name="Text 25"/>
+          <p:cNvSpPr/>
+          <p:nvPr/>
+        </p:nvSpPr>
+        <p:spPr>
+          <a:xfrm>
+            <a:off x="9843287" y="1773936"/>
+            <a:ext cx="1543736" cy="310896"/>
+          </a:xfrm>
+          <a:prstGeom prst="rect">
+            <a:avLst/>
+          </a:prstGeom>
+          <a:noFill/>
+          <a:ln/>
+        </p:spPr>
+        <p:txBody>
+          <a:bodyPr wrap="square" lIns="0" tIns="0" rIns="0" bIns="0" rtlCol="0" anchor="ctr"/>
+          <a:lstStyle/>
+          <a:p>
+            <a:pPr indent="0" marL="0">
+              <a:buNone/>
+            </a:pPr>
+            <a:r>
+              <a:rPr lang="en-US" sz="1250" b="1" dirty="0">
+                <a:solidFill>
+                  <a:srgbClr val="1B3A5C"/>
+                </a:solidFill>
+                <a:latin typeface="맑은 고딕" pitchFamily="34" charset="0"/>
+                <a:ea typeface="맑은 고딕" pitchFamily="34" charset="-122"/>
+                <a:cs typeface="맑은 고딕" pitchFamily="34" charset="-120"/>
+              </a:rPr>
+              <a:t>열회수면 퇴적</a:t>
+            </a:r>
+            <a:endParaRPr lang="en-US" sz="1250" dirty="0"/>
+          </a:p>
+        </p:txBody>
+      </p:sp>
+      <p:sp>
+        <p:nvSpPr>
+          <p:cNvPr id="28" name="Text 26"/>
+          <p:cNvSpPr/>
+          <p:nvPr/>
+        </p:nvSpPr>
+        <p:spPr>
+          <a:xfrm>
+            <a:off x="9440951" y="2194560"/>
+            <a:ext cx="1946072" cy="694944"/>
+          </a:xfrm>
+          <a:prstGeom prst="rect">
+            <a:avLst/>
+          </a:prstGeom>
+          <a:noFill/>
+          <a:ln/>
+        </p:spPr>
+        <p:txBody>
+          <a:bodyPr wrap="square" lIns="0" tIns="0" rIns="0" bIns="0" rtlCol="0" anchor="t"/>
+          <a:lstStyle/>
+          <a:p>
+            <a:pPr indent="0" marL="0">
+              <a:lnSpc>
+                <a:spcPts val="1500"/>
+              </a:lnSpc>
+              <a:buNone/>
+            </a:pPr>
+            <a:r>
+              <a:rPr lang="en-US" sz="1050" dirty="0">
+                <a:solidFill>
+                  <a:srgbClr val="3D4A5C"/>
+                </a:solidFill>
+                <a:latin typeface="맑은 고딕" pitchFamily="34" charset="0"/>
+                <a:ea typeface="맑은 고딕" pitchFamily="34" charset="-122"/>
+                <a:cs typeface="맑은 고딕" pitchFamily="34" charset="-120"/>
+              </a:rPr>
+              <a:t>이후 모든 연소 사이클의</a:t>
+            </a:r>
+            <a:endParaRPr lang="en-US" sz="1050" dirty="0"/>
+          </a:p>
+          <a:p>
+            <a:pPr indent="0" marL="0">
+              <a:lnSpc>
+                <a:spcPts val="1500"/>
+              </a:lnSpc>
+              <a:buNone/>
+            </a:pPr>
+            <a:r>
+              <a:rPr lang="en-US" sz="1050" dirty="0">
+                <a:solidFill>
+                  <a:srgbClr val="3D4A5C"/>
+                </a:solidFill>
+                <a:latin typeface="맑은 고딕" pitchFamily="34" charset="0"/>
+                <a:ea typeface="맑은 고딕" pitchFamily="34" charset="-122"/>
+                <a:cs typeface="맑은 고딕" pitchFamily="34" charset="-120"/>
+              </a:rPr>
+              <a:t>효율이 함께 떨어집니다</a:t>
+            </a:r>
+            <a:endParaRPr lang="en-US" sz="1050" dirty="0"/>
+          </a:p>
+        </p:txBody>
+      </p:sp>
+      <p:sp>
+        <p:nvSpPr>
+          <p:cNvPr id="29" name="Shape 27"/>
+          <p:cNvSpPr/>
+          <p:nvPr/>
+        </p:nvSpPr>
+        <p:spPr>
+          <a:xfrm>
+            <a:off x="566928" y="3273552"/>
+            <a:ext cx="5358384" cy="1700784"/>
+          </a:xfrm>
+          <a:prstGeom prst="roundRect">
+            <a:avLst>
+              <a:gd name="adj" fmla="val 7527"/>
+            </a:avLst>
+          </a:prstGeom>
+          <a:solidFill>
+            <a:srgbClr val="1B3A5C"/>
+          </a:solidFill>
+          <a:ln w="9525">
+            <a:solidFill>
+              <a:srgbClr val="1B3A5C"/>
+            </a:solidFill>
+            <a:prstDash val="solid"/>
+          </a:ln>
+          <a:effectLst>
+            <a:outerShdw sx="100000" sy="100000" kx="0" ky="0" algn="bl" rotWithShape="0" blurRad="127000" dist="25400" dir="5400000">
+              <a:srgbClr val="9BAAC4">
+                <a:alpha val="22000"/>
+              </a:srgbClr>
+            </a:outerShdw>
+          </a:effectLst>
+        </p:spPr>
+      </p:sp>
+      <p:sp>
+        <p:nvSpPr>
+          <p:cNvPr id="30" name="Text 28"/>
+          <p:cNvSpPr/>
+          <p:nvPr/>
+        </p:nvSpPr>
+        <p:spPr>
+          <a:xfrm>
+            <a:off x="841248" y="3474720"/>
+            <a:ext cx="4809744" cy="310896"/>
+          </a:xfrm>
+          <a:prstGeom prst="rect">
+            <a:avLst/>
+          </a:prstGeom>
+          <a:noFill/>
+          <a:ln/>
+        </p:spPr>
+        <p:txBody>
+          <a:bodyPr wrap="square" lIns="0" tIns="0" rIns="0" bIns="0" rtlCol="0" anchor="ctr"/>
+          <a:lstStyle/>
+          <a:p>
+            <a:pPr indent="0" marL="0">
+              <a:buNone/>
+            </a:pPr>
+            <a:r>
+              <a:rPr lang="en-US" sz="1400" b="1" dirty="0">
+                <a:solidFill>
+                  <a:srgbClr val="E17B34"/>
+                </a:solidFill>
+                <a:latin typeface="맑은 고딕" pitchFamily="34" charset="0"/>
+                <a:ea typeface="맑은 고딕" pitchFamily="34" charset="-122"/>
+                <a:cs typeface="맑은 고딕" pitchFamily="34" charset="-120"/>
+              </a:rPr>
+              <a:t>그래서 한 곳만 손봐서는 안 됩니다</a:t>
+            </a:r>
+            <a:endParaRPr lang="en-US" sz="1400" dirty="0"/>
+          </a:p>
+        </p:txBody>
+      </p:sp>
+      <p:sp>
+        <p:nvSpPr>
+          <p:cNvPr id="31" name="Text 29"/>
+          <p:cNvSpPr/>
+          <p:nvPr/>
+        </p:nvSpPr>
+        <p:spPr>
+          <a:xfrm>
+            <a:off x="841248" y="3840480"/>
+            <a:ext cx="4809744" cy="1005840"/>
+          </a:xfrm>
+          <a:prstGeom prst="rect">
+            <a:avLst/>
+          </a:prstGeom>
+          <a:noFill/>
+          <a:ln/>
+        </p:spPr>
+        <p:txBody>
+          <a:bodyPr wrap="square" lIns="0" tIns="0" rIns="0" bIns="0" rtlCol="0" anchor="t"/>
+          <a:lstStyle/>
+          <a:p>
+            <a:pPr indent="0" marL="0">
+              <a:lnSpc>
+                <a:spcPts val="1700"/>
+              </a:lnSpc>
+              <a:buNone/>
+            </a:pPr>
+            <a:r>
+              <a:rPr lang="en-US" sz="1150" dirty="0">
+                <a:solidFill>
+                  <a:srgbClr val="FFFFFF"/>
+                </a:solidFill>
+                <a:latin typeface="맑은 고딕" pitchFamily="34" charset="0"/>
+                <a:ea typeface="맑은 고딕" pitchFamily="34" charset="-122"/>
+                <a:cs typeface="맑은 고딕" pitchFamily="34" charset="-120"/>
+              </a:rPr>
+              <a:t>앞 단계의 손실이 뒤 단계의 손실로 그대로 넘어갑니다. </a:t>
+            </a:r>
+            <a:endParaRPr lang="en-US" sz="1150" dirty="0"/>
+          </a:p>
+          <a:p>
+            <a:pPr indent="0" marL="0">
+              <a:lnSpc>
+                <a:spcPts val="1700"/>
+              </a:lnSpc>
+              <a:buNone/>
+            </a:pPr>
+            <a:r>
+              <a:rPr lang="en-US" sz="1150" dirty="0">
+                <a:solidFill>
+                  <a:srgbClr val="D6E0EE"/>
+                </a:solidFill>
+                <a:latin typeface="맑은 고딕" pitchFamily="34" charset="0"/>
+                <a:ea typeface="맑은 고딕" pitchFamily="34" charset="-122"/>
+                <a:cs typeface="맑은 고딕" pitchFamily="34" charset="-120"/>
+              </a:rPr>
+              <a:t>저장에서 잃은 연료는 연소에서 되찾을 수 없고, 연소에서 만든 매연은 열회수 효율을 계속 갉아먹습니다.</a:t>
+            </a:r>
+            <a:endParaRPr lang="en-US" sz="1150" dirty="0"/>
+          </a:p>
+          <a:p>
+            <a:pPr indent="0" marL="0">
+              <a:lnSpc>
+                <a:spcPts val="1700"/>
+              </a:lnSpc>
+              <a:buNone/>
+            </a:pPr>
+            <a:r>
+              <a:rPr lang="en-US" sz="700" dirty="0">
+                <a:solidFill>
+                  <a:srgbClr val="000000"/>
+                </a:solidFill>
+              </a:rPr>
+              <a:t> </a:t>
+            </a:r>
+            <a:endParaRPr lang="en-US" sz="1150" dirty="0"/>
+          </a:p>
+          <a:p>
+            <a:pPr indent="0" marL="0">
+              <a:lnSpc>
+                <a:spcPts val="1700"/>
+              </a:lnSpc>
+              <a:buNone/>
+            </a:pPr>
+            <a:r>
+              <a:rPr lang="en-US" sz="1150" b="1" dirty="0">
+                <a:solidFill>
+                  <a:srgbClr val="FFFFFF"/>
+                </a:solidFill>
+                <a:latin typeface="맑은 고딕" pitchFamily="34" charset="0"/>
+                <a:ea typeface="맑은 고딕" pitchFamily="34" charset="-122"/>
+                <a:cs typeface="맑은 고딕" pitchFamily="34" charset="-120"/>
+              </a:rPr>
+              <a:t>계통은 서로 연결되어 있고, 하나로 관리할 때 반응합니다.</a:t>
+            </a:r>
+            <a:endParaRPr lang="en-US" sz="1150" dirty="0"/>
+          </a:p>
+        </p:txBody>
+      </p:sp>
+      <p:sp>
+        <p:nvSpPr>
+          <p:cNvPr id="32" name="Shape 30"/>
+          <p:cNvSpPr/>
+          <p:nvPr/>
+        </p:nvSpPr>
+        <p:spPr>
+          <a:xfrm>
+            <a:off x="6263640" y="3273552"/>
+            <a:ext cx="5358384" cy="1700784"/>
+          </a:xfrm>
+          <a:prstGeom prst="roundRect">
+            <a:avLst>
+              <a:gd name="adj" fmla="val 7527"/>
+            </a:avLst>
+          </a:prstGeom>
+          <a:solidFill>
+            <a:srgbClr val="FFFFFF"/>
+          </a:solidFill>
+          <a:ln w="9525">
+            <a:solidFill>
+              <a:srgbClr val="EDF1F8"/>
+            </a:solidFill>
+            <a:prstDash val="solid"/>
+          </a:ln>
+          <a:effectLst>
+            <a:outerShdw sx="100000" sy="100000" kx="0" ky="0" algn="bl" rotWithShape="0" blurRad="127000" dist="25400" dir="5400000">
+              <a:srgbClr val="9BAAC4">
+                <a:alpha val="22000"/>
+              </a:srgbClr>
+            </a:outerShdw>
+          </a:effectLst>
+        </p:spPr>
+      </p:sp>
+      <p:sp>
+        <p:nvSpPr>
+          <p:cNvPr id="33" name="Text 31"/>
+          <p:cNvSpPr/>
+          <p:nvPr/>
+        </p:nvSpPr>
+        <p:spPr>
+          <a:xfrm>
+            <a:off x="6519672" y="3456432"/>
+            <a:ext cx="4846320" cy="219456"/>
+          </a:xfrm>
+          <a:prstGeom prst="rect">
+            <a:avLst/>
+          </a:prstGeom>
+          <a:noFill/>
+          <a:ln/>
+        </p:spPr>
+        <p:txBody>
+          <a:bodyPr wrap="square" lIns="0" tIns="0" rIns="0" bIns="0" rtlCol="0" anchor="ctr"/>
+          <a:lstStyle/>
+          <a:p>
+            <a:pPr indent="0" marL="0">
+              <a:buNone/>
+            </a:pPr>
+            <a:r>
+              <a:rPr lang="en-US" sz="950" b="1" spc="180" kern="0" dirty="0">
+                <a:solidFill>
+                  <a:srgbClr val="2E5C8A"/>
+                </a:solidFill>
+                <a:latin typeface="맑은 고딕" pitchFamily="34" charset="0"/>
+                <a:ea typeface="맑은 고딕" pitchFamily="34" charset="-122"/>
+                <a:cs typeface="맑은 고딕" pitchFamily="34" charset="-120"/>
+              </a:rPr>
+              <a:t>WHAT INTEGRATED MANAGEMENT DELIVERS</a:t>
+            </a:r>
+            <a:endParaRPr lang="en-US" sz="950" dirty="0"/>
+          </a:p>
+        </p:txBody>
+      </p:sp>
+      <p:sp>
+        <p:nvSpPr>
+          <p:cNvPr id="34" name="Shape 32"/>
+          <p:cNvSpPr/>
+          <p:nvPr/>
+        </p:nvSpPr>
+        <p:spPr>
+          <a:xfrm>
+            <a:off x="6519672" y="3813048"/>
+            <a:ext cx="118872" cy="118872"/>
+          </a:xfrm>
+          <a:prstGeom prst="roundRect">
+            <a:avLst>
+              <a:gd name="adj" fmla="val 50000"/>
+            </a:avLst>
+          </a:prstGeom>
+          <a:solidFill>
+            <a:srgbClr val="2E7D5B"/>
+          </a:solidFill>
+          <a:ln w="12700">
+            <a:solidFill>
+              <a:srgbClr val="333333"/>
+            </a:solidFill>
+            <a:prstDash val="solid"/>
+          </a:ln>
+        </p:spPr>
+      </p:sp>
+      <p:sp>
+        <p:nvSpPr>
+          <p:cNvPr id="35" name="Text 33"/>
+          <p:cNvSpPr/>
+          <p:nvPr/>
+        </p:nvSpPr>
+        <p:spPr>
+          <a:xfrm>
+            <a:off x="6739128" y="3730752"/>
+            <a:ext cx="2231136" cy="292608"/>
+          </a:xfrm>
+          <a:prstGeom prst="rect">
+            <a:avLst/>
+          </a:prstGeom>
+          <a:noFill/>
+          <a:ln/>
+        </p:spPr>
+        <p:txBody>
+          <a:bodyPr wrap="square" lIns="0" tIns="0" rIns="0" bIns="0" rtlCol="0" anchor="ctr"/>
+          <a:lstStyle/>
+          <a:p>
+            <a:pPr indent="0" marL="0">
+              <a:buNone/>
+            </a:pPr>
+            <a:r>
+              <a:rPr lang="en-US" sz="1050" b="1" dirty="0">
+                <a:solidFill>
+                  <a:srgbClr val="1B3A5C"/>
+                </a:solidFill>
+                <a:latin typeface="맑은 고딕" pitchFamily="34" charset="0"/>
+                <a:ea typeface="맑은 고딕" pitchFamily="34" charset="-122"/>
+                <a:cs typeface="맑은 고딕" pitchFamily="34" charset="-120"/>
+              </a:rPr>
+              <a:t>슬러지 손실 감소  </a:t>
+            </a:r>
+            <a:pPr indent="0" marL="0">
+              <a:buNone/>
+            </a:pPr>
+            <a:r>
+              <a:rPr lang="en-US" sz="900" dirty="0">
+                <a:solidFill>
+                  <a:srgbClr val="8A94A6"/>
+                </a:solidFill>
+                <a:latin typeface="맑은 고딕" pitchFamily="34" charset="0"/>
+                <a:ea typeface="맑은 고딕" pitchFamily="34" charset="-122"/>
+                <a:cs typeface="맑은 고딕" pitchFamily="34" charset="-120"/>
+              </a:rPr>
+              <a:t>폐기 연료 ↓</a:t>
+            </a:r>
+            <a:endParaRPr lang="en-US" sz="1050" dirty="0"/>
+          </a:p>
+        </p:txBody>
+      </p:sp>
+      <p:sp>
+        <p:nvSpPr>
+          <p:cNvPr id="36" name="Shape 34"/>
+          <p:cNvSpPr/>
+          <p:nvPr/>
+        </p:nvSpPr>
+        <p:spPr>
+          <a:xfrm>
+            <a:off x="8970264" y="3813048"/>
+            <a:ext cx="118872" cy="118872"/>
+          </a:xfrm>
+          <a:prstGeom prst="roundRect">
+            <a:avLst>
+              <a:gd name="adj" fmla="val 50000"/>
+            </a:avLst>
+          </a:prstGeom>
+          <a:solidFill>
+            <a:srgbClr val="2E7D5B"/>
+          </a:solidFill>
+          <a:ln w="12700">
+            <a:solidFill>
+              <a:srgbClr val="333333"/>
+            </a:solidFill>
+            <a:prstDash val="solid"/>
+          </a:ln>
+        </p:spPr>
+      </p:sp>
+      <p:sp>
+        <p:nvSpPr>
+          <p:cNvPr id="37" name="Text 35"/>
+          <p:cNvSpPr/>
+          <p:nvPr/>
+        </p:nvSpPr>
+        <p:spPr>
+          <a:xfrm>
+            <a:off x="9189720" y="3730752"/>
+            <a:ext cx="2231136" cy="292608"/>
+          </a:xfrm>
+          <a:prstGeom prst="rect">
+            <a:avLst/>
+          </a:prstGeom>
+          <a:noFill/>
+          <a:ln/>
+        </p:spPr>
+        <p:txBody>
+          <a:bodyPr wrap="square" lIns="0" tIns="0" rIns="0" bIns="0" rtlCol="0" anchor="ctr"/>
+          <a:lstStyle/>
+          <a:p>
+            <a:pPr indent="0" marL="0">
+              <a:buNone/>
+            </a:pPr>
+            <a:r>
+              <a:rPr lang="en-US" sz="1050" b="1" dirty="0">
+                <a:solidFill>
+                  <a:srgbClr val="1B3A5C"/>
+                </a:solidFill>
+                <a:latin typeface="맑은 고딕" pitchFamily="34" charset="0"/>
+                <a:ea typeface="맑은 고딕" pitchFamily="34" charset="-122"/>
+                <a:cs typeface="맑은 고딕" pitchFamily="34" charset="-120"/>
+              </a:rPr>
+              <a:t>SFOC 저하  </a:t>
+            </a:r>
+            <a:pPr indent="0" marL="0">
+              <a:buNone/>
+            </a:pPr>
+            <a:r>
+              <a:rPr lang="en-US" sz="900" dirty="0">
+                <a:solidFill>
+                  <a:srgbClr val="8A94A6"/>
+                </a:solidFill>
+                <a:latin typeface="맑은 고딕" pitchFamily="34" charset="0"/>
+                <a:ea typeface="맑은 고딕" pitchFamily="34" charset="-122"/>
+                <a:cs typeface="맑은 고딕" pitchFamily="34" charset="-120"/>
+              </a:rPr>
+              <a:t>같은 출력에 연료 ↓</a:t>
+            </a:r>
+            <a:endParaRPr lang="en-US" sz="1050" dirty="0"/>
+          </a:p>
+        </p:txBody>
+      </p:sp>
+      <p:sp>
+        <p:nvSpPr>
+          <p:cNvPr id="38" name="Shape 36"/>
+          <p:cNvSpPr/>
+          <p:nvPr/>
+        </p:nvSpPr>
+        <p:spPr>
+          <a:xfrm>
+            <a:off x="6519672" y="4215384"/>
+            <a:ext cx="118872" cy="118872"/>
+          </a:xfrm>
+          <a:prstGeom prst="roundRect">
+            <a:avLst>
+              <a:gd name="adj" fmla="val 50000"/>
+            </a:avLst>
+          </a:prstGeom>
+          <a:solidFill>
+            <a:srgbClr val="2E7D5B"/>
+          </a:solidFill>
+          <a:ln w="12700">
+            <a:solidFill>
+              <a:srgbClr val="333333"/>
+            </a:solidFill>
+            <a:prstDash val="solid"/>
+          </a:ln>
+        </p:spPr>
+      </p:sp>
+      <p:sp>
+        <p:nvSpPr>
+          <p:cNvPr id="39" name="Text 37"/>
+          <p:cNvSpPr/>
+          <p:nvPr/>
+        </p:nvSpPr>
+        <p:spPr>
+          <a:xfrm>
+            <a:off x="6739128" y="4133088"/>
+            <a:ext cx="2231136" cy="292608"/>
+          </a:xfrm>
+          <a:prstGeom prst="rect">
+            <a:avLst/>
+          </a:prstGeom>
+          <a:noFill/>
+          <a:ln/>
+        </p:spPr>
+        <p:txBody>
+          <a:bodyPr wrap="square" lIns="0" tIns="0" rIns="0" bIns="0" rtlCol="0" anchor="ctr"/>
+          <a:lstStyle/>
+          <a:p>
+            <a:pPr indent="0" marL="0">
+              <a:buNone/>
+            </a:pPr>
+            <a:r>
+              <a:rPr lang="en-US" sz="1050" b="1" dirty="0">
+                <a:solidFill>
+                  <a:srgbClr val="1B3A5C"/>
+                </a:solidFill>
+                <a:latin typeface="맑은 고딕" pitchFamily="34" charset="0"/>
+                <a:ea typeface="맑은 고딕" pitchFamily="34" charset="-122"/>
+                <a:cs typeface="맑은 고딕" pitchFamily="34" charset="-120"/>
+              </a:rPr>
+              <a:t>비계획 정비 감소  </a:t>
+            </a:r>
+            <a:pPr indent="0" marL="0">
+              <a:buNone/>
+            </a:pPr>
+            <a:r>
+              <a:rPr lang="en-US" sz="900" dirty="0">
+                <a:solidFill>
+                  <a:srgbClr val="8A94A6"/>
+                </a:solidFill>
+                <a:latin typeface="맑은 고딕" pitchFamily="34" charset="0"/>
+                <a:ea typeface="맑은 고딕" pitchFamily="34" charset="-122"/>
+                <a:cs typeface="맑은 고딕" pitchFamily="34" charset="-120"/>
+              </a:rPr>
+              <a:t>정유기 · 필터 · 펌프</a:t>
+            </a:r>
+            <a:endParaRPr lang="en-US" sz="1050" dirty="0"/>
+          </a:p>
+        </p:txBody>
+      </p:sp>
+      <p:sp>
+        <p:nvSpPr>
+          <p:cNvPr id="40" name="Shape 38"/>
+          <p:cNvSpPr/>
+          <p:nvPr/>
+        </p:nvSpPr>
+        <p:spPr>
+          <a:xfrm>
+            <a:off x="8970264" y="4215384"/>
+            <a:ext cx="118872" cy="118872"/>
+          </a:xfrm>
+          <a:prstGeom prst="roundRect">
+            <a:avLst>
+              <a:gd name="adj" fmla="val 50000"/>
+            </a:avLst>
+          </a:prstGeom>
+          <a:solidFill>
+            <a:srgbClr val="2E7D5B"/>
+          </a:solidFill>
+          <a:ln w="12700">
+            <a:solidFill>
+              <a:srgbClr val="333333"/>
+            </a:solidFill>
+            <a:prstDash val="solid"/>
+          </a:ln>
+        </p:spPr>
+      </p:sp>
+      <p:sp>
+        <p:nvSpPr>
+          <p:cNvPr id="41" name="Text 39"/>
+          <p:cNvSpPr/>
+          <p:nvPr/>
+        </p:nvSpPr>
+        <p:spPr>
+          <a:xfrm>
+            <a:off x="9189720" y="4133088"/>
+            <a:ext cx="2231136" cy="292608"/>
+          </a:xfrm>
+          <a:prstGeom prst="rect">
+            <a:avLst/>
+          </a:prstGeom>
+          <a:noFill/>
+          <a:ln/>
+        </p:spPr>
+        <p:txBody>
+          <a:bodyPr wrap="square" lIns="0" tIns="0" rIns="0" bIns="0" rtlCol="0" anchor="ctr"/>
+          <a:lstStyle/>
+          <a:p>
+            <a:pPr indent="0" marL="0">
+              <a:buNone/>
+            </a:pPr>
+            <a:r>
+              <a:rPr lang="en-US" sz="1050" b="1" dirty="0">
+                <a:solidFill>
+                  <a:srgbClr val="1B3A5C"/>
+                </a:solidFill>
+                <a:latin typeface="맑은 고딕" pitchFamily="34" charset="0"/>
+                <a:ea typeface="맑은 고딕" pitchFamily="34" charset="-122"/>
+                <a:cs typeface="맑은 고딕" pitchFamily="34" charset="-120"/>
+              </a:rPr>
+              <a:t>청소 주기 연장  </a:t>
+            </a:r>
+            <a:pPr indent="0" marL="0">
+              <a:buNone/>
+            </a:pPr>
+            <a:r>
+              <a:rPr lang="en-US" sz="900" dirty="0">
+                <a:solidFill>
+                  <a:srgbClr val="8A94A6"/>
+                </a:solidFill>
+                <a:latin typeface="맑은 고딕" pitchFamily="34" charset="0"/>
+                <a:ea typeface="맑은 고딕" pitchFamily="34" charset="-122"/>
+                <a:cs typeface="맑은 고딕" pitchFamily="34" charset="-120"/>
+              </a:rPr>
+              <a:t>계통 청결 유지</a:t>
+            </a:r>
+            <a:endParaRPr lang="en-US" sz="1050" dirty="0"/>
+          </a:p>
+        </p:txBody>
+      </p:sp>
+      <p:sp>
+        <p:nvSpPr>
+          <p:cNvPr id="42" name="Shape 40"/>
+          <p:cNvSpPr/>
+          <p:nvPr/>
+        </p:nvSpPr>
+        <p:spPr>
+          <a:xfrm>
+            <a:off x="6519672" y="4617720"/>
+            <a:ext cx="118872" cy="118872"/>
+          </a:xfrm>
+          <a:prstGeom prst="roundRect">
+            <a:avLst>
+              <a:gd name="adj" fmla="val 50000"/>
+            </a:avLst>
+          </a:prstGeom>
+          <a:solidFill>
+            <a:srgbClr val="2E7D5B"/>
+          </a:solidFill>
+          <a:ln w="12700">
+            <a:solidFill>
+              <a:srgbClr val="333333"/>
+            </a:solidFill>
+            <a:prstDash val="solid"/>
+          </a:ln>
+        </p:spPr>
+      </p:sp>
+      <p:sp>
+        <p:nvSpPr>
+          <p:cNvPr id="43" name="Text 41"/>
+          <p:cNvSpPr/>
+          <p:nvPr/>
+        </p:nvSpPr>
+        <p:spPr>
+          <a:xfrm>
+            <a:off x="6739128" y="4535424"/>
+            <a:ext cx="2231136" cy="292608"/>
+          </a:xfrm>
+          <a:prstGeom prst="rect">
+            <a:avLst/>
+          </a:prstGeom>
+          <a:noFill/>
+          <a:ln/>
+        </p:spPr>
+        <p:txBody>
+          <a:bodyPr wrap="square" lIns="0" tIns="0" rIns="0" bIns="0" rtlCol="0" anchor="ctr"/>
+          <a:lstStyle/>
+          <a:p>
+            <a:pPr indent="0" marL="0">
+              <a:buNone/>
+            </a:pPr>
+            <a:r>
+              <a:rPr lang="en-US" sz="1050" b="1" dirty="0">
+                <a:solidFill>
+                  <a:srgbClr val="1B3A5C"/>
+                </a:solidFill>
+                <a:latin typeface="맑은 고딕" pitchFamily="34" charset="0"/>
+                <a:ea typeface="맑은 고딕" pitchFamily="34" charset="-122"/>
+                <a:cs typeface="맑은 고딕" pitchFamily="34" charset="-120"/>
+              </a:rPr>
+              <a:t>CII 반영  </a:t>
+            </a:r>
+            <a:pPr indent="0" marL="0">
+              <a:buNone/>
+            </a:pPr>
+            <a:r>
+              <a:rPr lang="en-US" sz="900" dirty="0">
+                <a:solidFill>
+                  <a:srgbClr val="8A94A6"/>
+                </a:solidFill>
+                <a:latin typeface="맑은 고딕" pitchFamily="34" charset="0"/>
+                <a:ea typeface="맑은 고딕" pitchFamily="34" charset="-122"/>
+                <a:cs typeface="맑은 고딕" pitchFamily="34" charset="-120"/>
+              </a:rPr>
+              <a:t>문서화된 개선</a:t>
+            </a:r>
+            <a:endParaRPr lang="en-US" sz="1050" dirty="0"/>
+          </a:p>
+        </p:txBody>
+      </p:sp>
+      <p:sp>
+        <p:nvSpPr>
+          <p:cNvPr id="44" name="Shape 42"/>
+          <p:cNvSpPr/>
+          <p:nvPr/>
+        </p:nvSpPr>
+        <p:spPr>
+          <a:xfrm>
+            <a:off x="566928" y="5138928"/>
+            <a:ext cx="11057839" cy="786384"/>
+          </a:xfrm>
+          <a:prstGeom prst="roundRect">
+            <a:avLst>
+              <a:gd name="adj" fmla="val 11628"/>
+            </a:avLst>
+          </a:prstGeom>
+          <a:solidFill>
+            <a:srgbClr val="1B3A5C"/>
+          </a:solidFill>
+          <a:ln w="12700">
+            <a:solidFill>
+              <a:srgbClr val="1B3A5C"/>
+            </a:solidFill>
+            <a:prstDash val="solid"/>
+          </a:ln>
+        </p:spPr>
+      </p:sp>
+      <p:sp>
+        <p:nvSpPr>
+          <p:cNvPr id="45" name="Text 43"/>
+          <p:cNvSpPr/>
+          <p:nvPr/>
+        </p:nvSpPr>
+        <p:spPr>
+          <a:xfrm>
+            <a:off x="795528" y="5138928"/>
+            <a:ext cx="10600639" cy="786384"/>
+          </a:xfrm>
+          <a:prstGeom prst="rect">
+            <a:avLst/>
+          </a:prstGeom>
+          <a:noFill/>
+          <a:ln/>
+        </p:spPr>
+        <p:txBody>
+          <a:bodyPr wrap="square" lIns="0" tIns="0" rIns="0" bIns="0" rtlCol="0" anchor="ctr"/>
+          <a:lstStyle/>
+          <a:p>
+            <a:pPr algn="ctr" indent="0" marL="0">
+              <a:buNone/>
+            </a:pPr>
+            <a:r>
+              <a:rPr lang="en-US" sz="1700" b="1" dirty="0">
+                <a:solidFill>
+                  <a:srgbClr val="E17B34"/>
+                </a:solidFill>
+                <a:latin typeface="바탕" pitchFamily="34" charset="0"/>
+                <a:ea typeface="바탕" pitchFamily="34" charset="-122"/>
+                <a:cs typeface="바탕" pitchFamily="34" charset="-120"/>
+              </a:rPr>
+              <a:t>“ </a:t>
+            </a:r>
+            <a:pPr algn="ctr" indent="0" marL="0">
+              <a:buNone/>
+            </a:pPr>
+            <a:r>
+              <a:rPr lang="en-US" sz="1400" b="1" dirty="0">
+                <a:solidFill>
+                  <a:srgbClr val="FFFFFF"/>
+                </a:solidFill>
+                <a:latin typeface="맑은 고딕" pitchFamily="34" charset="0"/>
+                <a:ea typeface="맑은 고딕" pitchFamily="34" charset="-122"/>
+                <a:cs typeface="맑은 고딕" pitchFamily="34" charset="-120"/>
+              </a:rPr>
+              <a:t>목표는 벙커링한 모든 연료가 추진력으로 온전히 쓰일 기회를 갖게 하는 것입니다.</a:t>
+            </a:r>
+            <a:pPr algn="ctr" indent="0" marL="0">
+              <a:buNone/>
+            </a:pPr>
+            <a:r>
+              <a:rPr lang="en-US" sz="1700" b="1" dirty="0">
+                <a:solidFill>
+                  <a:srgbClr val="E17B34"/>
+                </a:solidFill>
+                <a:latin typeface="바탕" pitchFamily="34" charset="0"/>
+                <a:ea typeface="바탕" pitchFamily="34" charset="-122"/>
+                <a:cs typeface="바탕" pitchFamily="34" charset="-120"/>
+              </a:rPr>
+              <a:t> ”</a:t>
+            </a:r>
+            <a:endParaRPr lang="en-US" sz="1700" dirty="0"/>
+          </a:p>
+        </p:txBody>
+      </p:sp>
+      <p:sp>
+        <p:nvSpPr>
+          <p:cNvPr id="46" name="Text 44"/>
+          <p:cNvSpPr/>
+          <p:nvPr/>
+        </p:nvSpPr>
+        <p:spPr>
+          <a:xfrm>
+            <a:off x="566928" y="6053328"/>
+            <a:ext cx="11057839" cy="219456"/>
+          </a:xfrm>
+          <a:prstGeom prst="rect">
+            <a:avLst/>
+          </a:prstGeom>
+          <a:noFill/>
+          <a:ln/>
+        </p:spPr>
+        <p:txBody>
+          <a:bodyPr wrap="square" lIns="0" tIns="0" rIns="0" bIns="0" rtlCol="0" anchor="ctr"/>
+          <a:lstStyle/>
+          <a:p>
+            <a:pPr indent="0" marL="0">
+              <a:buNone/>
+            </a:pPr>
+            <a:r>
+              <a:rPr lang="en-US" sz="850" i="1" dirty="0">
+                <a:solidFill>
+                  <a:srgbClr val="8A94A6"/>
+                </a:solidFill>
+                <a:latin typeface="맑은 고딕" pitchFamily="34" charset="0"/>
+                <a:ea typeface="맑은 고딕" pitchFamily="34" charset="-122"/>
+                <a:cs typeface="맑은 고딕" pitchFamily="34" charset="-120"/>
+              </a:rPr>
+              <a:t>출처: Wilhelmsen Ships Service, Tank to Wake 및 Pre-combustion treatment 자료 · Section 01 실측 데이터</a:t>
+            </a:r>
+            <a:endParaRPr lang="en-US" sz="850" dirty="0"/>
           </a:p>
         </p:txBody>
       </p:sp>
@@ -13031,7 +16720,7 @@
                 <a:ea typeface="맑은 고딕" pitchFamily="34" charset="-122"/>
                 <a:cs typeface="맑은 고딕" pitchFamily="34" charset="-120"/>
               </a:rPr>
-              <a:t>MGO 공급이 늘었다고 안심할 수 없습니다. 인화점 미달은 품질 문제가 아니라 안전 문제입니다.</a:t>
+              <a:t>ECA 출입 시 연료 전환은 점도와 온도를 급격히 흔듭니다. 그만큼 계통이 예민해집니다.</a:t>
             </a:r>
             <a:pPr algn="ctr" indent="0" marL="0">
               <a:buNone/>
@@ -14222,7 +17911,7 @@
                 <a:ea typeface="맑은 고딕" pitchFamily="34" charset="-122"/>
                 <a:cs typeface="맑은 고딕" pitchFamily="34" charset="-120"/>
               </a:rPr>
-              <a:t>→ Section 02 에서 다룹니다</a:t>
+              <a:t>→ 관리 범위를 분리기 밖으로 넓혀야 합니다</a:t>
             </a:r>
             <a:endParaRPr lang="en-US" sz="1050" dirty="0"/>
           </a:p>

</xml_diff>